<commit_message>
Adiciona slides de matemática (gráficos) e biologia ao trabalho
Dois slides de matemática (valor esperado + gráfico de decaimento
exponencial; barras e rosca com dados de endividamento e adolescentes)
e um slide de biologia (dopamina, tolerância, córtex pré-frontal).

Co-Authored-By: Claude Fable 5 <noreply@anthropic.com>
Claude-Session: https://claude.ai/code/session_016ibD7bSDuWkAH5YBCiU9BC
</commit_message>
<xml_diff>
--- a/trabalho-vicio-em-bets/vicio-em-bets.pptx
+++ b/trabalho-vicio-em-bets/vicio-em-bets.pptx
@@ -13,9 +13,12 @@
     <p:sldId id="261" r:id="rId7"/>
     <p:sldId id="262" r:id="rId8"/>
     <p:sldId id="263" r:id="rId9"/>
+    <p:sldId id="264" r:id="rId10"/>
+    <p:sldId id="265" r:id="rId11"/>
+    <p:sldId id="266" r:id="rId12"/>
   </p:sldIdLst>
   <p:notesMasterIdLst>
-    <p:notesMasterId r:id="rId10"/>
+    <p:notesMasterId r:id="rId13"/>
   </p:notesMasterIdLst>
   <p:sldSz cx="9144000" cy="5143500"/>
   <p:notesSz cx="5143500" cy="9144000"/>
@@ -112,6 +115,834 @@
     </a:lvl9pPr>
   </p:defaultTextStyle>
 </p:presentation>
+</file>
+
+<file path=ppt/charts/chart1.xml><?xml version="1.0" encoding="utf-8"?>
+<c:chartSpace xmlns:c="http://schemas.openxmlformats.org/drawingml/2006/chart" xmlns:a="http://schemas.openxmlformats.org/drawingml/2006/main" xmlns:r="http://schemas.openxmlformats.org/officeDocument/2006/relationships">
+  <c:date1904 val="0"/>
+  <c:roundedCorners val="1"/>
+  <c:chart>
+    <c:title>
+      <c:tx>
+        <c:rich>
+          <a:bodyPr/>
+          <a:lstStyle/>
+          <a:p>
+            <a:pPr>
+              <a:defRPr sz="1100" b="0" i="0" u="none" strike="noStrike">
+                <a:solidFill>
+                  <a:srgbClr val="9BA7B4"/>
+                </a:solidFill>
+                <a:latin typeface="Calibri"/>
+              </a:defRPr>
+            </a:pPr>
+            <a:r>
+              <a:rPr sz="1100" b="0" i="0" u="none" strike="noStrike">
+                <a:solidFill>
+                  <a:srgbClr val="9BA7B4"/>
+                </a:solidFill>
+                <a:latin typeface="Calibri"/>
+              </a:rPr>
+              <a:t>R$ 100 reapostados: quanto sobra após n rodadas</a:t>
+            </a:r>
+          </a:p>
+        </c:rich>
+      </c:tx>
+      <c:layout/>
+      <c:overlay val="0"/>
+    </c:title>
+    <c:autoTitleDeleted val="0"/>
+    <c:plotArea>
+      <c:layout/>
+      <c:lineChart>
+        <c:varyColors val="0"/>
+        <c:ser>
+          <c:idx val="0"/>
+          <c:order val="0"/>
+          <c:tx>
+            <c:strRef>
+              <c:f>Sheet1!$B$1</c:f>
+              <c:strCache>
+                <c:ptCount val="1"/>
+                <c:pt idx="0">
+                  <c:v>Dinheiro esperado (R$)</c:v>
+                </c:pt>
+              </c:strCache>
+            </c:strRef>
+          </c:tx>
+          <c:spPr>
+            <a:solidFill>
+              <a:srgbClr val="F85149"/>
+            </a:solidFill>
+            <a:ln w="31750" cap="flat">
+              <a:solidFill>
+                <a:srgbClr val="F85149"/>
+              </a:solidFill>
+              <a:prstDash val="solid"/>
+              <a:round/>
+            </a:ln>
+            <a:effectLst/>
+          </c:spPr>
+          <c:invertIfNegative val="0"/>
+          <c:dLbls>
+            <c:numFmt formatCode="#,##0" sourceLinked="0"/>
+            <c:txPr>
+              <a:bodyPr/>
+              <a:lstStyle/>
+              <a:p>
+                <a:pPr>
+                  <a:defRPr b="0" i="0" strike="noStrike" sz="1200" u="none">
+                    <a:solidFill>
+                      <a:srgbClr val="000000"/>
+                    </a:solidFill>
+                    <a:latin typeface="Arial"/>
+                  </a:defRPr>
+                </a:pPr>
+              </a:p>
+            </c:txPr>
+            <c:showLegendKey val="0"/>
+            <c:showVal val="0"/>
+            <c:showCatName val="0"/>
+            <c:showSerName val="0"/>
+            <c:showPercent val="0"/>
+            <c:showBubbleSize val="0"/>
+            <c:showLeaderLines val="0"/>
+          </c:dLbls>
+          <c:marker>
+            <c:symbol val="circle"/>
+            <c:size val="5"/>
+            <c:spPr>
+              <a:solidFill>
+                <a:srgbClr val="F85149"/>
+              </a:solidFill>
+              <a:ln w="9525" cap="flat">
+                <a:solidFill>
+                  <a:srgbClr val="F85149"/>
+                </a:solidFill>
+                <a:prstDash val="solid"/>
+                <a:round/>
+              </a:ln>
+              <a:effectLst/>
+            </c:spPr>
+          </c:marker>
+          <c:cat>
+            <c:multiLvlStrRef>
+              <c:f>Sheet1!$A$2:$A$14</c:f>
+              <c:multiLvlStrCache>
+                <c:ptCount val="13"/>
+                <c:lvl>
+                  <c:pt idx="0">
+                    <c:v>0</c:v>
+                  </c:pt>
+                  <c:pt idx="1">
+                    <c:v>5</c:v>
+                  </c:pt>
+                  <c:pt idx="2">
+                    <c:v>10</c:v>
+                  </c:pt>
+                  <c:pt idx="3">
+                    <c:v>15</c:v>
+                  </c:pt>
+                  <c:pt idx="4">
+                    <c:v>20</c:v>
+                  </c:pt>
+                  <c:pt idx="5">
+                    <c:v>25</c:v>
+                  </c:pt>
+                  <c:pt idx="6">
+                    <c:v>30</c:v>
+                  </c:pt>
+                  <c:pt idx="7">
+                    <c:v>35</c:v>
+                  </c:pt>
+                  <c:pt idx="8">
+                    <c:v>40</c:v>
+                  </c:pt>
+                  <c:pt idx="9">
+                    <c:v>45</c:v>
+                  </c:pt>
+                  <c:pt idx="10">
+                    <c:v>50</c:v>
+                  </c:pt>
+                  <c:pt idx="11">
+                    <c:v>55</c:v>
+                  </c:pt>
+                  <c:pt idx="12">
+                    <c:v>60</c:v>
+                  </c:pt>
+                </c:lvl>
+              </c:multiLvlStrCache>
+            </c:multiLvlStrRef>
+          </c:cat>
+          <c:val>
+            <c:numRef>
+              <c:f>Sheet1!$B$2:$B$14</c:f>
+              <c:numCache>
+                <c:formatCode>General</c:formatCode>
+                <c:ptCount val="13"/>
+                <c:pt idx="0">
+                  <c:v>100</c:v>
+                </c:pt>
+                <c:pt idx="1">
+                  <c:v>85</c:v>
+                </c:pt>
+                <c:pt idx="2">
+                  <c:v>72.3</c:v>
+                </c:pt>
+                <c:pt idx="3">
+                  <c:v>61.5</c:v>
+                </c:pt>
+                <c:pt idx="4">
+                  <c:v>52.3</c:v>
+                </c:pt>
+                <c:pt idx="5">
+                  <c:v>44.5</c:v>
+                </c:pt>
+                <c:pt idx="6">
+                  <c:v>37.8</c:v>
+                </c:pt>
+                <c:pt idx="7">
+                  <c:v>32.2</c:v>
+                </c:pt>
+                <c:pt idx="8">
+                  <c:v>27.3</c:v>
+                </c:pt>
+                <c:pt idx="9">
+                  <c:v>23.2</c:v>
+                </c:pt>
+                <c:pt idx="10">
+                  <c:v>19.8</c:v>
+                </c:pt>
+                <c:pt idx="11">
+                  <c:v>16.8</c:v>
+                </c:pt>
+                <c:pt idx="12">
+                  <c:v>14.3</c:v>
+                </c:pt>
+              </c:numCache>
+            </c:numRef>
+          </c:val>
+          <c:smooth val="0"/>
+        </c:ser>
+        <c:dLbls>
+          <c:numFmt formatCode="#,##0" sourceLinked="0"/>
+          <c:txPr>
+            <a:bodyPr/>
+            <a:lstStyle/>
+            <a:p>
+              <a:pPr>
+                <a:defRPr b="0" i="0" strike="noStrike" sz="1200" u="none">
+                  <a:solidFill>
+                    <a:srgbClr val="000000"/>
+                  </a:solidFill>
+                  <a:latin typeface="Arial"/>
+                </a:defRPr>
+              </a:pPr>
+            </a:p>
+          </c:txPr>
+          <c:showLegendKey val="0"/>
+          <c:showVal val="0"/>
+          <c:showCatName val="0"/>
+          <c:showSerName val="0"/>
+          <c:showPercent val="0"/>
+          <c:showBubbleSize val="0"/>
+          <c:showLeaderLines val="0"/>
+        </c:dLbls>
+        <c:marker val="1"/>
+        <c:axId val="2094734554"/>
+        <c:axId val="2094734552"/>
+        <c:axId val="2094734556"/>
+      </c:lineChart>
+      <c:catAx>
+        <c:axId val="2094734554"/>
+        <c:scaling>
+          <c:orientation val="minMax"/>
+        </c:scaling>
+        <c:delete val="0"/>
+        <c:axPos val="b"/>
+        <c:title>
+          <c:tx>
+            <c:rich>
+              <a:bodyPr/>
+              <a:lstStyle/>
+              <a:p>
+                <a:pPr>
+                  <a:defRPr sz="1000" b="0" i="0" u="none" strike="noStrike">
+                    <a:solidFill>
+                      <a:srgbClr val="9BA7B4"/>
+                    </a:solidFill>
+                    <a:latin typeface="Arial"/>
+                  </a:defRPr>
+                </a:pPr>
+                <a:r>
+                  <a:rPr sz="1000" b="0" i="0" u="none" strike="noStrike">
+                    <a:solidFill>
+                      <a:srgbClr val="9BA7B4"/>
+                    </a:solidFill>
+                    <a:latin typeface="Arial"/>
+                  </a:rPr>
+                  <a:t>rodadas</a:t>
+                </a:r>
+              </a:p>
+            </c:rich>
+          </c:tx>
+          <c:layout/>
+          <c:overlay val="0"/>
+        </c:title>
+        <c:numFmt formatCode="General" sourceLinked="1"/>
+        <c:majorTickMark val="out"/>
+        <c:minorTickMark val="none"/>
+        <c:tickLblPos val="low"/>
+        <c:spPr>
+          <a:ln w="12700" cap="flat">
+            <a:solidFill>
+              <a:srgbClr val="888888"/>
+            </a:solidFill>
+            <a:prstDash val="solid"/>
+            <a:round/>
+          </a:ln>
+        </c:spPr>
+        <c:txPr>
+          <a:bodyPr/>
+          <a:lstStyle/>
+          <a:p>
+            <a:pPr>
+              <a:defRPr sz="1000" b="0" i="0" u="none" strike="noStrike">
+                <a:solidFill>
+                  <a:srgbClr val="9BA7B4"/>
+                </a:solidFill>
+                <a:latin typeface="Arial"/>
+              </a:defRPr>
+            </a:pPr>
+            <a:endParaRPr lang="en-US"/>
+          </a:p>
+        </c:txPr>
+        <c:crossAx val="2094734552"/>
+        <c:crosses val="autoZero"/>
+        <c:auto val="1"/>
+        <c:lblAlgn val="ctr"/>
+        <c:noMultiLvlLbl val="1"/>
+      </c:catAx>
+      <c:valAx>
+        <c:axId val="2094734552"/>
+        <c:scaling>
+          <c:orientation val="minMax"/>
+          <c:max val="100"/>
+          <c:min val="0"/>
+        </c:scaling>
+        <c:delete val="0"/>
+        <c:axPos val="l"/>
+        <c:majorGridlines>
+          <c:spPr>
+            <a:ln w="6350" cap="flat">
+              <a:solidFill>
+                <a:srgbClr val="2A3240"/>
+              </a:solidFill>
+              <a:prstDash val="solid"/>
+              <a:round/>
+            </a:ln>
+          </c:spPr>
+        </c:majorGridlines>
+        <c:numFmt formatCode="General" sourceLinked="0"/>
+        <c:majorTickMark val="out"/>
+        <c:minorTickMark val="none"/>
+        <c:tickLblPos val="nextTo"/>
+        <c:spPr>
+          <a:ln w="12700" cap="flat">
+            <a:solidFill>
+              <a:srgbClr val="888888"/>
+            </a:solidFill>
+            <a:prstDash val="solid"/>
+            <a:round/>
+          </a:ln>
+        </c:spPr>
+        <c:txPr>
+          <a:bodyPr/>
+          <a:lstStyle/>
+          <a:p>
+            <a:pPr>
+              <a:defRPr sz="1000" b="0" i="0" u="none" strike="noStrike">
+                <a:solidFill>
+                  <a:srgbClr val="9BA7B4"/>
+                </a:solidFill>
+                <a:latin typeface="Arial"/>
+              </a:defRPr>
+            </a:pPr>
+            <a:endParaRPr lang="en-US"/>
+          </a:p>
+        </c:txPr>
+        <c:crossAx val="2094734554"/>
+        <c:crosses val="autoZero"/>
+        <c:crossBetween val="between"/>
+      </c:valAx>
+      <c:spPr>
+        <a:noFill/>
+        <a:ln>
+          <a:noFill/>
+        </a:ln>
+        <a:effectLst/>
+      </c:spPr>
+    </c:plotArea>
+    <c:plotVisOnly val="1"/>
+    <c:dispBlanksAs val="span"/>
+  </c:chart>
+  <c:spPr>
+    <a:noFill/>
+    <a:ln>
+      <a:noFill/>
+    </a:ln>
+    <a:effectLst/>
+  </c:spPr>
+  <c:externalData r:id="rId1">
+    <c:autoUpdate val="0"/>
+  </c:externalData>
+</c:chartSpace>
+</file>
+
+<file path=ppt/charts/chart2.xml><?xml version="1.0" encoding="utf-8"?>
+<c:chartSpace xmlns:c="http://schemas.openxmlformats.org/drawingml/2006/chart" xmlns:a="http://schemas.openxmlformats.org/drawingml/2006/main" xmlns:r="http://schemas.openxmlformats.org/officeDocument/2006/relationships">
+  <c:date1904 val="0"/>
+  <c:roundedCorners val="1"/>
+  <c:chart>
+    <c:title>
+      <c:tx>
+        <c:rich>
+          <a:bodyPr/>
+          <a:lstStyle/>
+          <a:p>
+            <a:pPr>
+              <a:defRPr sz="1100" b="0" i="0" u="none" strike="noStrike">
+                <a:solidFill>
+                  <a:srgbClr val="9BA7B4"/>
+                </a:solidFill>
+                <a:latin typeface="Calibri"/>
+              </a:defRPr>
+            </a:pPr>
+            <a:r>
+              <a:rPr sz="1100" b="0" i="0" u="none" strike="noStrike">
+                <a:solidFill>
+                  <a:srgbClr val="9BA7B4"/>
+                </a:solidFill>
+                <a:latin typeface="Calibri"/>
+              </a:rPr>
+              <a:t>Perfil dos apostadores brasileiros (%)</a:t>
+            </a:r>
+          </a:p>
+        </c:rich>
+      </c:tx>
+      <c:layout/>
+      <c:overlay val="0"/>
+    </c:title>
+    <c:autoTitleDeleted val="0"/>
+    <c:plotArea>
+      <c:layout/>
+      <c:barChart>
+        <c:barDir val="bar"/>
+        <c:grouping val="clustered"/>
+        <c:varyColors val="0"/>
+        <c:ser>
+          <c:idx val="0"/>
+          <c:order val="0"/>
+          <c:tx>
+            <c:strRef>
+              <c:f>Sheet1!$B$1</c:f>
+              <c:strCache>
+                <c:ptCount val="1"/>
+                <c:pt idx="0">
+                  <c:v>% dos apostadores</c:v>
+                </c:pt>
+              </c:strCache>
+            </c:strRef>
+          </c:tx>
+          <c:spPr>
+            <a:solidFill>
+              <a:srgbClr val="E3B341"/>
+            </a:solidFill>
+            <a:effectLst/>
+          </c:spPr>
+          <c:invertIfNegative val="0"/>
+          <c:dLbls>
+            <c:numFmt formatCode="0.0&quot;%&quot;" sourceLinked="0"/>
+            <c:txPr>
+              <a:bodyPr/>
+              <a:lstStyle/>
+              <a:p>
+                <a:pPr>
+                  <a:defRPr b="0" i="0" strike="noStrike" sz="1100" u="none">
+                    <a:solidFill>
+                      <a:srgbClr val="F0F6FC"/>
+                    </a:solidFill>
+                    <a:latin typeface="Calibri"/>
+                  </a:defRPr>
+                </a:pPr>
+              </a:p>
+            </c:txPr>
+            <c:showLegendKey val="0"/>
+            <c:showVal val="1"/>
+            <c:showCatName val="0"/>
+            <c:showSerName val="0"/>
+            <c:showPercent val="0"/>
+            <c:showBubbleSize val="0"/>
+            <c:showLeaderLines val="0"/>
+          </c:dLbls>
+          <c:cat>
+            <c:multiLvlStrRef>
+              <c:f>Sheet1!$A$2:$A$4</c:f>
+              <c:multiLvlStrCache>
+                <c:ptCount val="3"/>
+                <c:lvl>
+                  <c:pt idx="0">
+                    <c:v>Gastam mais de R$ 1 mil por mês</c:v>
+                  </c:pt>
+                  <c:pt idx="1">
+                    <c:v>Ganham até 2 salários mínimos</c:v>
+                  </c:pt>
+                  <c:pt idx="2">
+                    <c:v>Se endividaram após começar a apostar</c:v>
+                  </c:pt>
+                </c:lvl>
+              </c:multiLvlStrCache>
+            </c:multiLvlStrRef>
+          </c:cat>
+          <c:val>
+            <c:numRef>
+              <c:f>Sheet1!$B$2:$B$4</c:f>
+              <c:numCache>
+                <c:formatCode>General</c:formatCode>
+                <c:ptCount val="3"/>
+                <c:pt idx="0">
+                  <c:v>30</c:v>
+                </c:pt>
+                <c:pt idx="1">
+                  <c:v>38.6</c:v>
+                </c:pt>
+                <c:pt idx="2">
+                  <c:v>39.7</c:v>
+                </c:pt>
+              </c:numCache>
+            </c:numRef>
+          </c:val>
+        </c:ser>
+        <c:dLbls>
+          <c:numFmt formatCode="0.0&quot;%&quot;" sourceLinked="0"/>
+          <c:txPr>
+            <a:bodyPr/>
+            <a:lstStyle/>
+            <a:p>
+              <a:pPr>
+                <a:defRPr b="0" i="0" strike="noStrike" sz="1100" u="none">
+                  <a:solidFill>
+                    <a:srgbClr val="F0F6FC"/>
+                  </a:solidFill>
+                  <a:latin typeface="Calibri"/>
+                </a:defRPr>
+              </a:pPr>
+            </a:p>
+          </c:txPr>
+          <c:showLegendKey val="0"/>
+          <c:showVal val="1"/>
+          <c:showCatName val="0"/>
+          <c:showSerName val="0"/>
+          <c:showPercent val="0"/>
+          <c:showBubbleSize val="0"/>
+          <c:showLeaderLines val="0"/>
+        </c:dLbls>
+        <c:gapWidth val="60"/>
+        <c:overlap val="0"/>
+        <c:axId val="2094734554"/>
+        <c:axId val="2094734552"/>
+        <c:axId val="2094734556"/>
+      </c:barChart>
+      <c:catAx>
+        <c:axId val="2094734554"/>
+        <c:scaling>
+          <c:orientation val="minMax"/>
+        </c:scaling>
+        <c:delete val="0"/>
+        <c:axPos val="l"/>
+        <c:numFmt formatCode="General" sourceLinked="1"/>
+        <c:majorTickMark val="out"/>
+        <c:minorTickMark val="none"/>
+        <c:tickLblPos val="nextTo"/>
+        <c:spPr>
+          <a:ln w="12700" cap="flat">
+            <a:solidFill>
+              <a:srgbClr val="888888"/>
+            </a:solidFill>
+            <a:prstDash val="solid"/>
+            <a:round/>
+          </a:ln>
+        </c:spPr>
+        <c:txPr>
+          <a:bodyPr/>
+          <a:lstStyle/>
+          <a:p>
+            <a:pPr>
+              <a:defRPr sz="1050" b="0" i="0" u="none" strike="noStrike">
+                <a:solidFill>
+                  <a:srgbClr val="F0F6FC"/>
+                </a:solidFill>
+                <a:latin typeface="Arial"/>
+              </a:defRPr>
+            </a:pPr>
+            <a:endParaRPr lang="en-US"/>
+          </a:p>
+        </c:txPr>
+        <c:crossAx val="2094734552"/>
+        <c:crosses val="autoZero"/>
+        <c:auto val="1"/>
+        <c:lblAlgn val="ctr"/>
+        <c:noMultiLvlLbl val="1"/>
+      </c:catAx>
+      <c:valAx>
+        <c:axId val="2094734552"/>
+        <c:scaling>
+          <c:orientation val="minMax"/>
+          <c:max val="50"/>
+        </c:scaling>
+        <c:delete val="1"/>
+        <c:axPos val="b"/>
+        <c:numFmt formatCode="General" sourceLinked="0"/>
+        <c:majorTickMark val="out"/>
+        <c:minorTickMark val="none"/>
+        <c:tickLblPos val="low"/>
+        <c:spPr>
+          <a:ln w="12700" cap="flat">
+            <a:solidFill>
+              <a:srgbClr val="888888"/>
+            </a:solidFill>
+            <a:prstDash val="solid"/>
+            <a:round/>
+          </a:ln>
+        </c:spPr>
+        <c:txPr>
+          <a:bodyPr/>
+          <a:lstStyle/>
+          <a:p>
+            <a:pPr>
+              <a:defRPr sz="1200" b="0" i="0" u="none" strike="noStrike">
+                <a:solidFill>
+                  <a:srgbClr val="000000"/>
+                </a:solidFill>
+                <a:latin typeface="Arial"/>
+              </a:defRPr>
+            </a:pPr>
+            <a:endParaRPr lang="en-US"/>
+          </a:p>
+        </c:txPr>
+        <c:crossAx val="2094734554"/>
+        <c:crosses val="autoZero"/>
+        <c:crossBetween val="between"/>
+      </c:valAx>
+      <c:spPr>
+        <a:noFill/>
+        <a:ln>
+          <a:noFill/>
+        </a:ln>
+        <a:effectLst/>
+      </c:spPr>
+    </c:plotArea>
+    <c:plotVisOnly val="1"/>
+    <c:dispBlanksAs val="span"/>
+  </c:chart>
+  <c:spPr>
+    <a:noFill/>
+    <a:ln>
+      <a:noFill/>
+    </a:ln>
+    <a:effectLst/>
+  </c:spPr>
+  <c:externalData r:id="rId1">
+    <c:autoUpdate val="0"/>
+  </c:externalData>
+</c:chartSpace>
+</file>
+
+<file path=ppt/charts/chart3.xml><?xml version="1.0" encoding="utf-8"?>
+<c:chartSpace xmlns:c="http://schemas.openxmlformats.org/drawingml/2006/chart" xmlns:a="http://schemas.openxmlformats.org/drawingml/2006/main" xmlns:r="http://schemas.openxmlformats.org/officeDocument/2006/relationships">
+  <c:date1904 val="0"/>
+  <c:roundedCorners val="1"/>
+  <c:chart>
+    <c:autoTitleDeleted val="1"/>
+    <c:plotArea>
+      <c:layout/>
+      <c:doughnutChart>
+        <c:varyColors val="1"/>
+        <c:ser>
+          <c:idx val="0"/>
+          <c:order val="0"/>
+          <c:tx>
+            <c:strRef>
+              <c:f>Sheet1!$B$1</c:f>
+              <c:strCache>
+                <c:ptCount val="1"/>
+                <c:pt idx="0">
+                  <c:v>Adolescentes</c:v>
+                </c:pt>
+              </c:strCache>
+            </c:strRef>
+          </c:tx>
+          <c:spPr>
+            <a:solidFill>
+              <a:schemeClr val="accent1"/>
+            </a:solidFill>
+            <a:ln w="9525" cap="flat">
+              <a:solidFill>
+                <a:srgbClr val="F9F9F9"/>
+              </a:solidFill>
+              <a:prstDash val="solid"/>
+              <a:round/>
+            </a:ln>
+            <a:effectLst/>
+          </c:spPr>
+          <c:dPt>
+            <c:idx val="0"/>
+            <c:bubble3D val="0"/>
+            <c:spPr>
+              <a:solidFill>
+                <a:srgbClr val="F85149"/>
+              </a:solidFill>
+              <a:effectLst/>
+            </c:spPr>
+          </c:dPt>
+          <c:dPt>
+            <c:idx val="1"/>
+            <c:bubble3D val="0"/>
+            <c:spPr>
+              <a:solidFill>
+                <a:srgbClr val="2A3240"/>
+              </a:solidFill>
+              <a:effectLst/>
+            </c:spPr>
+          </c:dPt>
+          <c:dLbls>
+            <c:dLbl>
+              <c:idx val="0"/>
+              <c:numFmt formatCode="General" sourceLinked="0"/>
+              <c:spPr/>
+              <c:txPr>
+                <a:bodyPr/>
+                <a:lstStyle/>
+                <a:p>
+                  <a:pPr>
+                    <a:defRPr sz="1200" b="0" i="0" u="none" strike="noStrike">
+                      <a:solidFill>
+                        <a:srgbClr val="000000"/>
+                      </a:solidFill>
+                      <a:latin typeface="Arial"/>
+                    </a:defRPr>
+                  </a:pPr>
+                </a:p>
+              </c:txPr>
+              <c:showLegendKey val="0"/>
+              <c:showVal val="0"/>
+              <c:showCatName val="0"/>
+              <c:showSerName val="0"/>
+              <c:showPercent val="0"/>
+              <c:showBubbleSize val="0"/>
+            </c:dLbl>
+            <c:dLbl>
+              <c:idx val="1"/>
+              <c:numFmt formatCode="General" sourceLinked="0"/>
+              <c:spPr/>
+              <c:txPr>
+                <a:bodyPr/>
+                <a:lstStyle/>
+                <a:p>
+                  <a:pPr>
+                    <a:defRPr sz="1200" b="0" i="0" u="none" strike="noStrike">
+                      <a:solidFill>
+                        <a:srgbClr val="000000"/>
+                      </a:solidFill>
+                      <a:latin typeface="Arial"/>
+                    </a:defRPr>
+                  </a:pPr>
+                </a:p>
+              </c:txPr>
+              <c:showLegendKey val="0"/>
+              <c:showVal val="0"/>
+              <c:showCatName val="0"/>
+              <c:showSerName val="0"/>
+              <c:showPercent val="0"/>
+              <c:showBubbleSize val="0"/>
+            </c:dLbl>
+            <c:numFmt formatCode="General" sourceLinked="0"/>
+            <c:txPr>
+              <a:bodyPr/>
+              <a:lstStyle/>
+              <a:p>
+                <a:pPr>
+                  <a:defRPr sz="1800" b="0" i="0" u="none" strike="noStrike">
+                    <a:solidFill>
+                      <a:srgbClr val="000000"/>
+                    </a:solidFill>
+                    <a:latin typeface="Arial"/>
+                  </a:defRPr>
+                </a:pPr>
+              </a:p>
+            </c:txPr>
+            <c:showLegendKey val="0"/>
+            <c:showVal val="0"/>
+            <c:showCatName val="1"/>
+            <c:showSerName val="0"/>
+            <c:showPercent val="1"/>
+            <c:showBubbleSize val="0"/>
+            <c:showLeaderLines val="0"/>
+          </c:dLbls>
+          <c:cat>
+            <c:strRef>
+              <c:f>Sheet1!$A$2:$A$3</c:f>
+              <c:strCache>
+                <c:ptCount val="2"/>
+                <c:pt idx="0">
+                  <c:v>Já apostaram</c:v>
+                </c:pt>
+                <c:pt idx="1">
+                  <c:v>Não apostaram</c:v>
+                </c:pt>
+              </c:strCache>
+            </c:strRef>
+          </c:cat>
+          <c:val>
+            <c:numRef>
+              <c:f>Sheet1!$B$2:$B$3</c:f>
+              <c:numCache>
+                <c:ptCount val="2"/>
+                <c:pt idx="0">
+                  <c:v>10.5</c:v>
+                </c:pt>
+                <c:pt idx="1">
+                  <c:v>89.5</c:v>
+                </c:pt>
+              </c:numCache>
+            </c:numRef>
+          </c:val>
+        </c:ser>
+        <c:firstSliceAng val="0"/>
+        <c:holeSize val="62"/>
+      </c:doughnutChart>
+      <c:spPr>
+        <a:noFill/>
+        <a:ln>
+          <a:noFill/>
+        </a:ln>
+        <a:effectLst/>
+      </c:spPr>
+    </c:plotArea>
+    <c:plotVisOnly val="1"/>
+    <c:dispBlanksAs val="span"/>
+  </c:chart>
+  <c:spPr>
+    <a:noFill/>
+    <a:ln>
+      <a:noFill/>
+    </a:ln>
+    <a:effectLst/>
+  </c:spPr>
+  <c:externalData r:id="rId1">
+    <c:autoUpdate val="0"/>
+  </c:externalData>
+</c:chartSpace>
 </file>
 
 <file path=ppt/notesMasters/notesMaster1.xml><?xml version="1.0" encoding="utf-8"?>
@@ -551,6 +1382,182 @@
 </p:notes>
 </file>
 
+<file path=ppt/notesSlides/notesSlide10.xml><?xml version="1.0" encoding="utf-8"?>
+<p:notes xmlns:a="http://schemas.openxmlformats.org/drawingml/2006/main" xmlns:r="http://schemas.openxmlformats.org/officeDocument/2006/relationships" xmlns:p="http://schemas.openxmlformats.org/presentationml/2006/main">
+  <p:cSld>
+    <p:spTree>
+      <p:nvGrpSpPr>
+        <p:cNvPr id="1" name=""/>
+        <p:cNvGrpSpPr/>
+        <p:nvPr/>
+      </p:nvGrpSpPr>
+      <p:grpSpPr>
+        <a:xfrm>
+          <a:off x="0" y="0"/>
+          <a:ext cx="0" cy="0"/>
+          <a:chOff x="0" y="0"/>
+          <a:chExt cx="0" cy="0"/>
+        </a:xfrm>
+      </p:grpSpPr>
+      <p:sp>
+        <p:nvSpPr>
+          <p:cNvPr id="2" name="Slide Image Placeholder 1"/>
+          <p:cNvSpPr>
+            <a:spLocks noGrp="1" noRot="1" noChangeAspect="1"/>
+          </p:cNvSpPr>
+          <p:nvPr>
+            <p:ph type="sldImg"/>
+          </p:nvPr>
+        </p:nvSpPr>
+        <p:spPr/>
+      </p:sp>
+      <p:sp>
+        <p:nvSpPr>
+          <p:cNvPr id="3" name="Notes Placeholder 2"/>
+          <p:cNvSpPr>
+            <a:spLocks noGrp="1"/>
+          </p:cNvSpPr>
+          <p:nvPr>
+            <p:ph type="body" idx="1"/>
+          </p:nvPr>
+        </p:nvSpPr>
+        <p:spPr/>
+        <p:txBody>
+          <a:bodyPr/>
+          <a:lstStyle/>
+          <a:p>
+            <a:r>
+              <a:rPr lang="en-US" dirty="0"/>
+              <a:t>Aqui entra o gancho do vídeo do grupo: o vídeo informativo É o 'meio' da nossa proposta — a nossa ação social na prática.</a:t>
+            </a:r>
+            <a:endParaRPr lang="en-US" dirty="0"/>
+          </a:p>
+        </p:txBody>
+      </p:sp>
+      <p:sp>
+        <p:nvSpPr>
+          <p:cNvPr id="4" name="Slide Number Placeholder 3"/>
+          <p:cNvSpPr>
+            <a:spLocks noGrp="1"/>
+          </p:cNvSpPr>
+          <p:nvPr>
+            <p:ph type="sldNum" sz="quarter" idx="10"/>
+          </p:nvPr>
+        </p:nvSpPr>
+        <p:spPr/>
+        <p:txBody>
+          <a:bodyPr/>
+          <a:lstStyle/>
+          <a:p>
+            <a:fld id="{F7021451-1387-4CA6-816F-3879F97B5CBC}" type="slidenum">
+              <a:rPr lang="en-US"/>
+              <a:t>10</a:t>
+            </a:fld>
+            <a:endParaRPr lang="en-US"/>
+          </a:p>
+        </p:txBody>
+      </p:sp>
+    </p:spTree>
+    <p:extLst>
+      <p:ext uri="{BB962C8B-B14F-4D97-AF65-F5344CB8AC3E}">
+        <p14:creationId xmlns:p14="http://schemas.microsoft.com/office/powerpoint/2010/main" val="1024086991"/>
+      </p:ext>
+    </p:extLst>
+  </p:cSld>
+  <p:clrMapOvr>
+    <a:masterClrMapping/>
+  </p:clrMapOvr>
+</p:notes>
+</file>
+
+<file path=ppt/notesSlides/notesSlide11.xml><?xml version="1.0" encoding="utf-8"?>
+<p:notes xmlns:a="http://schemas.openxmlformats.org/drawingml/2006/main" xmlns:r="http://schemas.openxmlformats.org/officeDocument/2006/relationships" xmlns:p="http://schemas.openxmlformats.org/presentationml/2006/main">
+  <p:cSld>
+    <p:spTree>
+      <p:nvGrpSpPr>
+        <p:cNvPr id="1" name=""/>
+        <p:cNvGrpSpPr/>
+        <p:nvPr/>
+      </p:nvGrpSpPr>
+      <p:grpSpPr>
+        <a:xfrm>
+          <a:off x="0" y="0"/>
+          <a:ext cx="0" cy="0"/>
+          <a:chOff x="0" y="0"/>
+          <a:chExt cx="0" cy="0"/>
+        </a:xfrm>
+      </p:grpSpPr>
+      <p:sp>
+        <p:nvSpPr>
+          <p:cNvPr id="2" name="Slide Image Placeholder 1"/>
+          <p:cNvSpPr>
+            <a:spLocks noGrp="1" noRot="1" noChangeAspect="1"/>
+          </p:cNvSpPr>
+          <p:nvPr>
+            <p:ph type="sldImg"/>
+          </p:nvPr>
+        </p:nvSpPr>
+        <p:spPr/>
+      </p:sp>
+      <p:sp>
+        <p:nvSpPr>
+          <p:cNvPr id="3" name="Notes Placeholder 2"/>
+          <p:cNvSpPr>
+            <a:spLocks noGrp="1"/>
+          </p:cNvSpPr>
+          <p:nvPr>
+            <p:ph type="body" idx="1"/>
+          </p:nvPr>
+        </p:nvSpPr>
+        <p:spPr/>
+        <p:txBody>
+          <a:bodyPr/>
+          <a:lstStyle/>
+          <a:p>
+            <a:r>
+              <a:rPr lang="en-US" dirty="0"/>
+              <a:t>Fechar com os canais de ajuda — isso mostra que a apresentação não só descreve o problema, mas aponta a saída.</a:t>
+            </a:r>
+            <a:endParaRPr lang="en-US" dirty="0"/>
+          </a:p>
+        </p:txBody>
+      </p:sp>
+      <p:sp>
+        <p:nvSpPr>
+          <p:cNvPr id="4" name="Slide Number Placeholder 3"/>
+          <p:cNvSpPr>
+            <a:spLocks noGrp="1"/>
+          </p:cNvSpPr>
+          <p:nvPr>
+            <p:ph type="sldNum" sz="quarter" idx="10"/>
+          </p:nvPr>
+        </p:nvSpPr>
+        <p:spPr/>
+        <p:txBody>
+          <a:bodyPr/>
+          <a:lstStyle/>
+          <a:p>
+            <a:fld id="{F7021451-1387-4CA6-816F-3879F97B5CBC}" type="slidenum">
+              <a:rPr lang="en-US"/>
+              <a:t>11</a:t>
+            </a:fld>
+            <a:endParaRPr lang="en-US"/>
+          </a:p>
+        </p:txBody>
+      </p:sp>
+    </p:spTree>
+    <p:extLst>
+      <p:ext uri="{BB962C8B-B14F-4D97-AF65-F5344CB8AC3E}">
+        <p14:creationId xmlns:p14="http://schemas.microsoft.com/office/powerpoint/2010/main" val="1024086991"/>
+      </p:ext>
+    </p:extLst>
+  </p:cSld>
+  <p:clrMapOvr>
+    <a:masterClrMapping/>
+  </p:clrMapOvr>
+</p:notes>
+</file>
+
 <file path=ppt/notesSlides/notesSlide2.xml><?xml version="1.0" encoding="utf-8"?>
 <p:notes xmlns:a="http://schemas.openxmlformats.org/drawingml/2006/main" xmlns:r="http://schemas.openxmlformats.org/officeDocument/2006/relationships" xmlns:p="http://schemas.openxmlformats.org/presentationml/2006/main">
   <p:cSld>
@@ -1037,7 +2044,7 @@
           <a:p>
             <a:r>
               <a:rPr lang="en-US" dirty="0"/>
-              <a:t>Aqui entra o gancho do vídeo do grupo: o vídeo informativo É o 'meio' da nossa proposta — a nossa ação social na prática.</a:t>
+              <a:t>Ponto de matemática: valor esperado e função exponencial. Se der tempo, mostrar que após 21 rodadas já se perdeu metade (0,968^21 ≈ 0,5 — meia-vida do dinheiro).</a:t>
             </a:r>
             <a:endParaRPr lang="en-US" dirty="0"/>
           </a:p>
@@ -1125,7 +2132,7 @@
           <a:p>
             <a:r>
               <a:rPr lang="en-US" dirty="0"/>
-              <a:t>Fechar com os canais de ajuda — isso mostra que a apresentação não só descreve o problema, mas aponta a saída.</a:t>
+              <a:t>Leitura de gráfico de barras e de setores — pontue: quase 4 em cada 10 apostadores se endividaram, e o público mais pobre é o mais atingido.</a:t>
             </a:r>
             <a:endParaRPr lang="en-US" dirty="0"/>
           </a:p>
@@ -1149,6 +2156,94 @@
             <a:fld id="{F7021451-1387-4CA6-816F-3879F97B5CBC}" type="slidenum">
               <a:rPr lang="en-US"/>
               <a:t>8</a:t>
+            </a:fld>
+            <a:endParaRPr lang="en-US"/>
+          </a:p>
+        </p:txBody>
+      </p:sp>
+    </p:spTree>
+    <p:extLst>
+      <p:ext uri="{BB962C8B-B14F-4D97-AF65-F5344CB8AC3E}">
+        <p14:creationId xmlns:p14="http://schemas.microsoft.com/office/powerpoint/2010/main" val="1024086991"/>
+      </p:ext>
+    </p:extLst>
+  </p:cSld>
+  <p:clrMapOvr>
+    <a:masterClrMapping/>
+  </p:clrMapOvr>
+</p:notes>
+</file>
+
+<file path=ppt/notesSlides/notesSlide9.xml><?xml version="1.0" encoding="utf-8"?>
+<p:notes xmlns:a="http://schemas.openxmlformats.org/drawingml/2006/main" xmlns:r="http://schemas.openxmlformats.org/officeDocument/2006/relationships" xmlns:p="http://schemas.openxmlformats.org/presentationml/2006/main">
+  <p:cSld>
+    <p:spTree>
+      <p:nvGrpSpPr>
+        <p:cNvPr id="1" name=""/>
+        <p:cNvGrpSpPr/>
+        <p:nvPr/>
+      </p:nvGrpSpPr>
+      <p:grpSpPr>
+        <a:xfrm>
+          <a:off x="0" y="0"/>
+          <a:ext cx="0" cy="0"/>
+          <a:chOff x="0" y="0"/>
+          <a:chExt cx="0" cy="0"/>
+        </a:xfrm>
+      </p:grpSpPr>
+      <p:sp>
+        <p:nvSpPr>
+          <p:cNvPr id="2" name="Slide Image Placeholder 1"/>
+          <p:cNvSpPr>
+            <a:spLocks noGrp="1" noRot="1" noChangeAspect="1"/>
+          </p:cNvSpPr>
+          <p:nvPr>
+            <p:ph type="sldImg"/>
+          </p:nvPr>
+        </p:nvSpPr>
+        <p:spPr/>
+      </p:sp>
+      <p:sp>
+        <p:nvSpPr>
+          <p:cNvPr id="3" name="Notes Placeholder 2"/>
+          <p:cNvSpPr>
+            <a:spLocks noGrp="1"/>
+          </p:cNvSpPr>
+          <p:nvPr>
+            <p:ph type="body" idx="1"/>
+          </p:nvPr>
+        </p:nvSpPr>
+        <p:spPr/>
+        <p:txBody>
+          <a:bodyPr/>
+          <a:lstStyle/>
+          <a:p>
+            <a:r>
+              <a:rPr lang="en-US" dirty="0"/>
+              <a:t>Ponto de biologia: dopamina, reforço intermitente, tolerância e maturação do córtex pré-frontal. Conectar com o slide 4 ('é doença'): aqui está o mecanismo da doença.</a:t>
+            </a:r>
+            <a:endParaRPr lang="en-US" dirty="0"/>
+          </a:p>
+        </p:txBody>
+      </p:sp>
+      <p:sp>
+        <p:nvSpPr>
+          <p:cNvPr id="4" name="Slide Number Placeholder 3"/>
+          <p:cNvSpPr>
+            <a:spLocks noGrp="1"/>
+          </p:cNvSpPr>
+          <p:nvPr>
+            <p:ph type="sldNum" sz="quarter" idx="10"/>
+          </p:nvPr>
+        </p:nvSpPr>
+        <p:spPr/>
+        <p:txBody>
+          <a:bodyPr/>
+          <a:lstStyle/>
+          <a:p>
+            <a:fld id="{F7021451-1387-4CA6-816F-3879F97B5CBC}" type="slidenum">
+              <a:rPr lang="en-US"/>
+              <a:t>9</a:t>
             </a:fld>
             <a:endParaRPr lang="en-US"/>
           </a:p>
@@ -1635,7 +2730,7 @@
                 <a:ea typeface="Calibri" pitchFamily="34" charset="-122"/>
                 <a:cs typeface="Calibri" pitchFamily="34" charset="-120"/>
               </a:rPr>
-              <a:t>Tese  •  Quatro por quês  •  Proposta de intervenção</a:t>
+              <a:t>Redação: tese e intervenção  •  Matemática: os números  •  Biologia: o cérebro no vício</a:t>
             </a:r>
             <a:endParaRPr lang="en-US" sz="1400" dirty="0"/>
           </a:p>
@@ -1677,6 +2772,1153 @@
               <a:t>[Nomes dos integrantes]  —  [Turma]  —  2026</a:t>
             </a:r>
             <a:endParaRPr lang="en-US" sz="1300" dirty="0"/>
+          </a:p>
+        </p:txBody>
+      </p:sp>
+    </p:spTree>
+  </p:cSld>
+  <p:clrMapOvr>
+    <a:masterClrMapping/>
+  </p:clrMapOvr>
+</p:sld>
+</file>
+
+<file path=ppt/slides/slide10.xml><?xml version="1.0" encoding="utf-8"?>
+<p:sld xmlns:a="http://schemas.openxmlformats.org/drawingml/2006/main" xmlns:r="http://schemas.openxmlformats.org/officeDocument/2006/relationships" xmlns:p="http://schemas.openxmlformats.org/presentationml/2006/main">
+  <p:cSld name="Slide 10">
+    <p:bg>
+      <p:bgPr>
+        <a:solidFill>
+          <a:srgbClr val="0D1117"/>
+        </a:solidFill>
+      </p:bgPr>
+    </p:bg>
+    <p:spTree>
+      <p:nvGrpSpPr>
+        <p:cNvPr id="1" name=""/>
+        <p:cNvGrpSpPr/>
+        <p:nvPr/>
+      </p:nvGrpSpPr>
+      <p:grpSpPr>
+        <a:xfrm>
+          <a:off x="0" y="0"/>
+          <a:ext cx="0" cy="0"/>
+          <a:chOff x="0" y="0"/>
+          <a:chExt cx="0" cy="0"/>
+        </a:xfrm>
+      </p:grpSpPr>
+      <p:sp>
+        <p:nvSpPr>
+          <p:cNvPr id="2" name="Text 0"/>
+          <p:cNvSpPr txBox="1"/>
+          <p:nvPr/>
+        </p:nvSpPr>
+        <p:spPr>
+          <a:xfrm>
+            <a:off x="640080" y="365760"/>
+            <a:ext cx="7863840" cy="548640"/>
+          </a:xfrm>
+          <a:prstGeom prst="rect">
+            <a:avLst/>
+          </a:prstGeom>
+          <a:noFill/>
+          <a:ln/>
+        </p:spPr>
+        <p:txBody>
+          <a:bodyPr wrap="square" lIns="0" tIns="0" rIns="0" bIns="0" rtlCol="0" anchor="ctr"/>
+          <a:lstStyle/>
+          <a:p>
+            <a:pPr indent="0" marL="0">
+              <a:buNone/>
+            </a:pPr>
+            <a:r>
+              <a:rPr lang="en-US" sz="3000" b="1" dirty="0">
+                <a:solidFill>
+                  <a:srgbClr val="F0F6FC"/>
+                </a:solidFill>
+                <a:latin typeface="Calibri" pitchFamily="34" charset="0"/>
+                <a:ea typeface="Calibri" pitchFamily="34" charset="-122"/>
+                <a:cs typeface="Calibri" pitchFamily="34" charset="-120"/>
+              </a:rPr>
+              <a:t>PROPOSTA DE INTERVENÇÃO</a:t>
+            </a:r>
+            <a:endParaRPr lang="en-US" sz="3000" dirty="0"/>
+          </a:p>
+        </p:txBody>
+      </p:sp>
+      <p:sp>
+        <p:nvSpPr>
+          <p:cNvPr id="3" name="Shape 1"/>
+          <p:cNvSpPr/>
+          <p:nvPr/>
+        </p:nvSpPr>
+        <p:spPr>
+          <a:xfrm>
+            <a:off x="640080" y="1143000"/>
+            <a:ext cx="1938528" cy="2331720"/>
+          </a:xfrm>
+          <a:prstGeom prst="roundRect">
+            <a:avLst>
+              <a:gd name="adj" fmla="val 4717"/>
+            </a:avLst>
+          </a:prstGeom>
+          <a:solidFill>
+            <a:srgbClr val="161C26"/>
+          </a:solidFill>
+          <a:ln/>
+        </p:spPr>
+      </p:sp>
+      <p:sp>
+        <p:nvSpPr>
+          <p:cNvPr id="4" name="Shape 2"/>
+          <p:cNvSpPr/>
+          <p:nvPr/>
+        </p:nvSpPr>
+        <p:spPr>
+          <a:xfrm>
+            <a:off x="804672" y="1307592"/>
+            <a:ext cx="502920" cy="502920"/>
+          </a:xfrm>
+          <a:prstGeom prst="ellipse">
+            <a:avLst/>
+          </a:prstGeom>
+          <a:solidFill>
+            <a:srgbClr val="1C2431"/>
+          </a:solidFill>
+          <a:ln/>
+        </p:spPr>
+      </p:sp>
+      <p:pic>
+        <p:nvPicPr>
+          <p:cNvPr id="5" name="Image 0" descr="preencoded.png">    </p:cNvPr>
+          <p:cNvPicPr>
+            <a:picLocks noChangeAspect="1"/>
+          </p:cNvPicPr>
+          <p:nvPr/>
+        </p:nvPicPr>
+        <p:blipFill>
+          <a:blip r:embed="rId1"/>
+          <a:stretch>
+            <a:fillRect/>
+          </a:stretch>
+        </p:blipFill>
+        <p:spPr>
+          <a:xfrm>
+            <a:off x="935431" y="1438351"/>
+            <a:ext cx="241402" cy="241402"/>
+          </a:xfrm>
+          <a:prstGeom prst="rect">
+            <a:avLst/>
+          </a:prstGeom>
+        </p:spPr>
+      </p:pic>
+      <p:sp>
+        <p:nvSpPr>
+          <p:cNvPr id="6" name="Text 3"/>
+          <p:cNvSpPr txBox="1"/>
+          <p:nvPr/>
+        </p:nvSpPr>
+        <p:spPr>
+          <a:xfrm>
+            <a:off x="804672" y="1920240"/>
+            <a:ext cx="1609344" cy="320040"/>
+          </a:xfrm>
+          <a:prstGeom prst="rect">
+            <a:avLst/>
+          </a:prstGeom>
+          <a:noFill/>
+          <a:ln/>
+        </p:spPr>
+        <p:txBody>
+          <a:bodyPr wrap="square" lIns="0" tIns="0" rIns="0" bIns="0" rtlCol="0" anchor="ctr"/>
+          <a:lstStyle/>
+          <a:p>
+            <a:pPr indent="0" marL="0">
+              <a:buNone/>
+            </a:pPr>
+            <a:r>
+              <a:rPr lang="en-US" sz="1400" b="1" dirty="0">
+                <a:solidFill>
+                  <a:srgbClr val="3FB950"/>
+                </a:solidFill>
+                <a:latin typeface="Calibri" pitchFamily="34" charset="0"/>
+                <a:ea typeface="Calibri" pitchFamily="34" charset="-122"/>
+                <a:cs typeface="Calibri" pitchFamily="34" charset="-120"/>
+              </a:rPr>
+              <a:t>AGENTE</a:t>
+            </a:r>
+            <a:endParaRPr lang="en-US" sz="1400" dirty="0"/>
+          </a:p>
+        </p:txBody>
+      </p:sp>
+      <p:sp>
+        <p:nvSpPr>
+          <p:cNvPr id="7" name="Text 4"/>
+          <p:cNvSpPr txBox="1"/>
+          <p:nvPr/>
+        </p:nvSpPr>
+        <p:spPr>
+          <a:xfrm>
+            <a:off x="804672" y="2240280"/>
+            <a:ext cx="1609344" cy="1097280"/>
+          </a:xfrm>
+          <a:prstGeom prst="rect">
+            <a:avLst/>
+          </a:prstGeom>
+          <a:noFill/>
+          <a:ln/>
+        </p:spPr>
+        <p:txBody>
+          <a:bodyPr wrap="square" lIns="0" tIns="0" rIns="0" bIns="0" rtlCol="0" anchor="t"/>
+          <a:lstStyle/>
+          <a:p>
+            <a:pPr indent="0" marL="0">
+              <a:lnSpc>
+                <a:spcPct val="110000"/>
+              </a:lnSpc>
+              <a:buNone/>
+            </a:pPr>
+            <a:r>
+              <a:rPr lang="en-US" sz="1150" dirty="0">
+                <a:solidFill>
+                  <a:srgbClr val="F0F6FC"/>
+                </a:solidFill>
+                <a:latin typeface="Calibri" pitchFamily="34" charset="0"/>
+                <a:ea typeface="Calibri" pitchFamily="34" charset="-122"/>
+                <a:cs typeface="Calibri" pitchFamily="34" charset="-120"/>
+              </a:rPr>
+              <a:t>Ministério da Saúde e escolas, em parceria com as prefeituras</a:t>
+            </a:r>
+            <a:endParaRPr lang="en-US" sz="1150" dirty="0"/>
+          </a:p>
+        </p:txBody>
+      </p:sp>
+      <p:sp>
+        <p:nvSpPr>
+          <p:cNvPr id="8" name="Shape 5"/>
+          <p:cNvSpPr/>
+          <p:nvPr/>
+        </p:nvSpPr>
+        <p:spPr>
+          <a:xfrm>
+            <a:off x="2779776" y="1143000"/>
+            <a:ext cx="1938528" cy="2331720"/>
+          </a:xfrm>
+          <a:prstGeom prst="roundRect">
+            <a:avLst>
+              <a:gd name="adj" fmla="val 4717"/>
+            </a:avLst>
+          </a:prstGeom>
+          <a:solidFill>
+            <a:srgbClr val="161C26"/>
+          </a:solidFill>
+          <a:ln/>
+        </p:spPr>
+      </p:sp>
+      <p:sp>
+        <p:nvSpPr>
+          <p:cNvPr id="9" name="Shape 6"/>
+          <p:cNvSpPr/>
+          <p:nvPr/>
+        </p:nvSpPr>
+        <p:spPr>
+          <a:xfrm>
+            <a:off x="2944368" y="1307592"/>
+            <a:ext cx="502920" cy="502920"/>
+          </a:xfrm>
+          <a:prstGeom prst="ellipse">
+            <a:avLst/>
+          </a:prstGeom>
+          <a:solidFill>
+            <a:srgbClr val="1C2431"/>
+          </a:solidFill>
+          <a:ln/>
+        </p:spPr>
+      </p:sp>
+      <p:pic>
+        <p:nvPicPr>
+          <p:cNvPr id="10" name="Image 1" descr="preencoded.png">    </p:cNvPr>
+          <p:cNvPicPr>
+            <a:picLocks noChangeAspect="1"/>
+          </p:cNvPicPr>
+          <p:nvPr/>
+        </p:nvPicPr>
+        <p:blipFill>
+          <a:blip r:embed="rId2"/>
+          <a:stretch>
+            <a:fillRect/>
+          </a:stretch>
+        </p:blipFill>
+        <p:spPr>
+          <a:xfrm>
+            <a:off x="3075127" y="1438351"/>
+            <a:ext cx="241402" cy="241402"/>
+          </a:xfrm>
+          <a:prstGeom prst="rect">
+            <a:avLst/>
+          </a:prstGeom>
+        </p:spPr>
+      </p:pic>
+      <p:sp>
+        <p:nvSpPr>
+          <p:cNvPr id="11" name="Text 7"/>
+          <p:cNvSpPr txBox="1"/>
+          <p:nvPr/>
+        </p:nvSpPr>
+        <p:spPr>
+          <a:xfrm>
+            <a:off x="2944368" y="1920240"/>
+            <a:ext cx="1609344" cy="320040"/>
+          </a:xfrm>
+          <a:prstGeom prst="rect">
+            <a:avLst/>
+          </a:prstGeom>
+          <a:noFill/>
+          <a:ln/>
+        </p:spPr>
+        <p:txBody>
+          <a:bodyPr wrap="square" lIns="0" tIns="0" rIns="0" bIns="0" rtlCol="0" anchor="ctr"/>
+          <a:lstStyle/>
+          <a:p>
+            <a:pPr indent="0" marL="0">
+              <a:buNone/>
+            </a:pPr>
+            <a:r>
+              <a:rPr lang="en-US" sz="1400" b="1" dirty="0">
+                <a:solidFill>
+                  <a:srgbClr val="3FB950"/>
+                </a:solidFill>
+                <a:latin typeface="Calibri" pitchFamily="34" charset="0"/>
+                <a:ea typeface="Calibri" pitchFamily="34" charset="-122"/>
+                <a:cs typeface="Calibri" pitchFamily="34" charset="-120"/>
+              </a:rPr>
+              <a:t>AÇÃO</a:t>
+            </a:r>
+            <a:endParaRPr lang="en-US" sz="1400" dirty="0"/>
+          </a:p>
+        </p:txBody>
+      </p:sp>
+      <p:sp>
+        <p:nvSpPr>
+          <p:cNvPr id="12" name="Text 8"/>
+          <p:cNvSpPr txBox="1"/>
+          <p:nvPr/>
+        </p:nvSpPr>
+        <p:spPr>
+          <a:xfrm>
+            <a:off x="2944368" y="2240280"/>
+            <a:ext cx="1609344" cy="1097280"/>
+          </a:xfrm>
+          <a:prstGeom prst="rect">
+            <a:avLst/>
+          </a:prstGeom>
+          <a:noFill/>
+          <a:ln/>
+        </p:spPr>
+        <p:txBody>
+          <a:bodyPr wrap="square" lIns="0" tIns="0" rIns="0" bIns="0" rtlCol="0" anchor="t"/>
+          <a:lstStyle/>
+          <a:p>
+            <a:pPr indent="0" marL="0">
+              <a:lnSpc>
+                <a:spcPct val="110000"/>
+              </a:lnSpc>
+              <a:buNone/>
+            </a:pPr>
+            <a:r>
+              <a:rPr lang="en-US" sz="1150" dirty="0">
+                <a:solidFill>
+                  <a:srgbClr val="F0F6FC"/>
+                </a:solidFill>
+                <a:latin typeface="Calibri" pitchFamily="34" charset="0"/>
+                <a:ea typeface="Calibri" pitchFamily="34" charset="-122"/>
+                <a:cs typeface="Calibri" pitchFamily="34" charset="-120"/>
+              </a:rPr>
+              <a:t>Campanha nacional de conscientização + ampliação do tratamento gratuito nos CAPS/SUS</a:t>
+            </a:r>
+            <a:endParaRPr lang="en-US" sz="1150" dirty="0"/>
+          </a:p>
+        </p:txBody>
+      </p:sp>
+      <p:sp>
+        <p:nvSpPr>
+          <p:cNvPr id="13" name="Shape 9"/>
+          <p:cNvSpPr/>
+          <p:nvPr/>
+        </p:nvSpPr>
+        <p:spPr>
+          <a:xfrm>
+            <a:off x="4919472" y="1143000"/>
+            <a:ext cx="1938528" cy="2331720"/>
+          </a:xfrm>
+          <a:prstGeom prst="roundRect">
+            <a:avLst>
+              <a:gd name="adj" fmla="val 4717"/>
+            </a:avLst>
+          </a:prstGeom>
+          <a:solidFill>
+            <a:srgbClr val="161C26"/>
+          </a:solidFill>
+          <a:ln/>
+        </p:spPr>
+      </p:sp>
+      <p:sp>
+        <p:nvSpPr>
+          <p:cNvPr id="14" name="Shape 10"/>
+          <p:cNvSpPr/>
+          <p:nvPr/>
+        </p:nvSpPr>
+        <p:spPr>
+          <a:xfrm>
+            <a:off x="5084064" y="1307592"/>
+            <a:ext cx="502920" cy="502920"/>
+          </a:xfrm>
+          <a:prstGeom prst="ellipse">
+            <a:avLst/>
+          </a:prstGeom>
+          <a:solidFill>
+            <a:srgbClr val="1C2431"/>
+          </a:solidFill>
+          <a:ln/>
+        </p:spPr>
+      </p:sp>
+      <p:pic>
+        <p:nvPicPr>
+          <p:cNvPr id="15" name="Image 2" descr="preencoded.png">    </p:cNvPr>
+          <p:cNvPicPr>
+            <a:picLocks noChangeAspect="1"/>
+          </p:cNvPicPr>
+          <p:nvPr/>
+        </p:nvPicPr>
+        <p:blipFill>
+          <a:blip r:embed="rId3"/>
+          <a:stretch>
+            <a:fillRect/>
+          </a:stretch>
+        </p:blipFill>
+        <p:spPr>
+          <a:xfrm>
+            <a:off x="5214823" y="1438351"/>
+            <a:ext cx="241402" cy="241402"/>
+          </a:xfrm>
+          <a:prstGeom prst="rect">
+            <a:avLst/>
+          </a:prstGeom>
+        </p:spPr>
+      </p:pic>
+      <p:sp>
+        <p:nvSpPr>
+          <p:cNvPr id="16" name="Text 11"/>
+          <p:cNvSpPr txBox="1"/>
+          <p:nvPr/>
+        </p:nvSpPr>
+        <p:spPr>
+          <a:xfrm>
+            <a:off x="5084064" y="1920240"/>
+            <a:ext cx="1609344" cy="320040"/>
+          </a:xfrm>
+          <a:prstGeom prst="rect">
+            <a:avLst/>
+          </a:prstGeom>
+          <a:noFill/>
+          <a:ln/>
+        </p:spPr>
+        <p:txBody>
+          <a:bodyPr wrap="square" lIns="0" tIns="0" rIns="0" bIns="0" rtlCol="0" anchor="ctr"/>
+          <a:lstStyle/>
+          <a:p>
+            <a:pPr indent="0" marL="0">
+              <a:buNone/>
+            </a:pPr>
+            <a:r>
+              <a:rPr lang="en-US" sz="1400" b="1" dirty="0">
+                <a:solidFill>
+                  <a:srgbClr val="3FB950"/>
+                </a:solidFill>
+                <a:latin typeface="Calibri" pitchFamily="34" charset="0"/>
+                <a:ea typeface="Calibri" pitchFamily="34" charset="-122"/>
+                <a:cs typeface="Calibri" pitchFamily="34" charset="-120"/>
+              </a:rPr>
+              <a:t>MEIO</a:t>
+            </a:r>
+            <a:endParaRPr lang="en-US" sz="1400" dirty="0"/>
+          </a:p>
+        </p:txBody>
+      </p:sp>
+      <p:sp>
+        <p:nvSpPr>
+          <p:cNvPr id="17" name="Text 12"/>
+          <p:cNvSpPr txBox="1"/>
+          <p:nvPr/>
+        </p:nvSpPr>
+        <p:spPr>
+          <a:xfrm>
+            <a:off x="5084064" y="2240280"/>
+            <a:ext cx="1609344" cy="1097280"/>
+          </a:xfrm>
+          <a:prstGeom prst="rect">
+            <a:avLst/>
+          </a:prstGeom>
+          <a:noFill/>
+          <a:ln/>
+        </p:spPr>
+        <p:txBody>
+          <a:bodyPr wrap="square" lIns="0" tIns="0" rIns="0" bIns="0" rtlCol="0" anchor="t"/>
+          <a:lstStyle/>
+          <a:p>
+            <a:pPr indent="0" marL="0">
+              <a:lnSpc>
+                <a:spcPct val="110000"/>
+              </a:lnSpc>
+              <a:buNone/>
+            </a:pPr>
+            <a:r>
+              <a:rPr lang="en-US" sz="1150" dirty="0">
+                <a:solidFill>
+                  <a:srgbClr val="F0F6FC"/>
+                </a:solidFill>
+                <a:latin typeface="Calibri" pitchFamily="34" charset="0"/>
+                <a:ea typeface="Calibri" pitchFamily="34" charset="-122"/>
+                <a:cs typeface="Calibri" pitchFamily="34" charset="-120"/>
+              </a:rPr>
+              <a:t>Vídeos informativos nas redes sociais, palestras nas escolas e divulgação dos canais de ajuda</a:t>
+            </a:r>
+            <a:endParaRPr lang="en-US" sz="1150" dirty="0"/>
+          </a:p>
+        </p:txBody>
+      </p:sp>
+      <p:sp>
+        <p:nvSpPr>
+          <p:cNvPr id="18" name="Shape 13"/>
+          <p:cNvSpPr/>
+          <p:nvPr/>
+        </p:nvSpPr>
+        <p:spPr>
+          <a:xfrm>
+            <a:off x="7059168" y="1143000"/>
+            <a:ext cx="1938528" cy="2331720"/>
+          </a:xfrm>
+          <a:prstGeom prst="roundRect">
+            <a:avLst>
+              <a:gd name="adj" fmla="val 4717"/>
+            </a:avLst>
+          </a:prstGeom>
+          <a:solidFill>
+            <a:srgbClr val="161C26"/>
+          </a:solidFill>
+          <a:ln/>
+        </p:spPr>
+      </p:sp>
+      <p:sp>
+        <p:nvSpPr>
+          <p:cNvPr id="19" name="Shape 14"/>
+          <p:cNvSpPr/>
+          <p:nvPr/>
+        </p:nvSpPr>
+        <p:spPr>
+          <a:xfrm>
+            <a:off x="7223760" y="1307592"/>
+            <a:ext cx="502920" cy="502920"/>
+          </a:xfrm>
+          <a:prstGeom prst="ellipse">
+            <a:avLst/>
+          </a:prstGeom>
+          <a:solidFill>
+            <a:srgbClr val="1C2431"/>
+          </a:solidFill>
+          <a:ln/>
+        </p:spPr>
+      </p:sp>
+      <p:pic>
+        <p:nvPicPr>
+          <p:cNvPr id="20" name="Image 3" descr="preencoded.png">    </p:cNvPr>
+          <p:cNvPicPr>
+            <a:picLocks noChangeAspect="1"/>
+          </p:cNvPicPr>
+          <p:nvPr/>
+        </p:nvPicPr>
+        <p:blipFill>
+          <a:blip r:embed="rId4"/>
+          <a:stretch>
+            <a:fillRect/>
+          </a:stretch>
+        </p:blipFill>
+        <p:spPr>
+          <a:xfrm>
+            <a:off x="7354519" y="1438351"/>
+            <a:ext cx="241402" cy="241402"/>
+          </a:xfrm>
+          <a:prstGeom prst="rect">
+            <a:avLst/>
+          </a:prstGeom>
+        </p:spPr>
+      </p:pic>
+      <p:sp>
+        <p:nvSpPr>
+          <p:cNvPr id="21" name="Text 15"/>
+          <p:cNvSpPr txBox="1"/>
+          <p:nvPr/>
+        </p:nvSpPr>
+        <p:spPr>
+          <a:xfrm>
+            <a:off x="7223760" y="1920240"/>
+            <a:ext cx="1609344" cy="320040"/>
+          </a:xfrm>
+          <a:prstGeom prst="rect">
+            <a:avLst/>
+          </a:prstGeom>
+          <a:noFill/>
+          <a:ln/>
+        </p:spPr>
+        <p:txBody>
+          <a:bodyPr wrap="square" lIns="0" tIns="0" rIns="0" bIns="0" rtlCol="0" anchor="ctr"/>
+          <a:lstStyle/>
+          <a:p>
+            <a:pPr indent="0" marL="0">
+              <a:buNone/>
+            </a:pPr>
+            <a:r>
+              <a:rPr lang="en-US" sz="1400" b="1" dirty="0">
+                <a:solidFill>
+                  <a:srgbClr val="3FB950"/>
+                </a:solidFill>
+                <a:latin typeface="Calibri" pitchFamily="34" charset="0"/>
+                <a:ea typeface="Calibri" pitchFamily="34" charset="-122"/>
+                <a:cs typeface="Calibri" pitchFamily="34" charset="-120"/>
+              </a:rPr>
+              <a:t>FINALIDADE</a:t>
+            </a:r>
+            <a:endParaRPr lang="en-US" sz="1400" dirty="0"/>
+          </a:p>
+        </p:txBody>
+      </p:sp>
+      <p:sp>
+        <p:nvSpPr>
+          <p:cNvPr id="22" name="Text 16"/>
+          <p:cNvSpPr txBox="1"/>
+          <p:nvPr/>
+        </p:nvSpPr>
+        <p:spPr>
+          <a:xfrm>
+            <a:off x="7223760" y="2240280"/>
+            <a:ext cx="1609344" cy="1097280"/>
+          </a:xfrm>
+          <a:prstGeom prst="rect">
+            <a:avLst/>
+          </a:prstGeom>
+          <a:noFill/>
+          <a:ln/>
+        </p:spPr>
+        <p:txBody>
+          <a:bodyPr wrap="square" lIns="0" tIns="0" rIns="0" bIns="0" rtlCol="0" anchor="t"/>
+          <a:lstStyle/>
+          <a:p>
+            <a:pPr indent="0" marL="0">
+              <a:lnSpc>
+                <a:spcPct val="110000"/>
+              </a:lnSpc>
+              <a:buNone/>
+            </a:pPr>
+            <a:r>
+              <a:rPr lang="en-US" sz="1150" dirty="0">
+                <a:solidFill>
+                  <a:srgbClr val="F0F6FC"/>
+                </a:solidFill>
+                <a:latin typeface="Calibri" pitchFamily="34" charset="0"/>
+                <a:ea typeface="Calibri" pitchFamily="34" charset="-122"/>
+                <a:cs typeface="Calibri" pitchFamily="34" charset="-120"/>
+              </a:rPr>
+              <a:t>Reduzir o número de viciados e proteger os jovens antes da primeira aposta</a:t>
+            </a:r>
+            <a:endParaRPr lang="en-US" sz="1150" dirty="0"/>
+          </a:p>
+        </p:txBody>
+      </p:sp>
+      <p:sp>
+        <p:nvSpPr>
+          <p:cNvPr id="23" name="Shape 17"/>
+          <p:cNvSpPr/>
+          <p:nvPr/>
+        </p:nvSpPr>
+        <p:spPr>
+          <a:xfrm>
+            <a:off x="640080" y="3703320"/>
+            <a:ext cx="7863840" cy="1005840"/>
+          </a:xfrm>
+          <a:prstGeom prst="roundRect">
+            <a:avLst>
+              <a:gd name="adj" fmla="val 9091"/>
+            </a:avLst>
+          </a:prstGeom>
+          <a:solidFill>
+            <a:srgbClr val="1C2431"/>
+          </a:solidFill>
+          <a:ln/>
+        </p:spPr>
+      </p:sp>
+      <p:sp>
+        <p:nvSpPr>
+          <p:cNvPr id="24" name="Shape 18"/>
+          <p:cNvSpPr/>
+          <p:nvPr/>
+        </p:nvSpPr>
+        <p:spPr>
+          <a:xfrm>
+            <a:off x="822960" y="3950208"/>
+            <a:ext cx="502920" cy="502920"/>
+          </a:xfrm>
+          <a:prstGeom prst="ellipse">
+            <a:avLst/>
+          </a:prstGeom>
+          <a:solidFill>
+            <a:srgbClr val="161C26"/>
+          </a:solidFill>
+          <a:ln/>
+        </p:spPr>
+      </p:sp>
+      <p:pic>
+        <p:nvPicPr>
+          <p:cNvPr id="25" name="Image 4" descr="preencoded.png">    </p:cNvPr>
+          <p:cNvPicPr>
+            <a:picLocks noChangeAspect="1"/>
+          </p:cNvPicPr>
+          <p:nvPr/>
+        </p:nvPicPr>
+        <p:blipFill>
+          <a:blip r:embed="rId5"/>
+          <a:stretch>
+            <a:fillRect/>
+          </a:stretch>
+        </p:blipFill>
+        <p:spPr>
+          <a:xfrm>
+            <a:off x="953719" y="4080967"/>
+            <a:ext cx="241402" cy="241402"/>
+          </a:xfrm>
+          <a:prstGeom prst="rect">
+            <a:avLst/>
+          </a:prstGeom>
+        </p:spPr>
+      </p:pic>
+      <p:sp>
+        <p:nvSpPr>
+          <p:cNvPr id="26" name="Text 19"/>
+          <p:cNvSpPr txBox="1"/>
+          <p:nvPr/>
+        </p:nvSpPr>
+        <p:spPr>
+          <a:xfrm>
+            <a:off x="1508760" y="3794760"/>
+            <a:ext cx="6812280" cy="822960"/>
+          </a:xfrm>
+          <a:prstGeom prst="rect">
+            <a:avLst/>
+          </a:prstGeom>
+          <a:noFill/>
+          <a:ln/>
+        </p:spPr>
+        <p:txBody>
+          <a:bodyPr wrap="square" lIns="0" tIns="0" rIns="0" bIns="0" rtlCol="0" anchor="ctr"/>
+          <a:lstStyle/>
+          <a:p>
+            <a:pPr indent="0" marL="0">
+              <a:lnSpc>
+                <a:spcPct val="110000"/>
+              </a:lnSpc>
+              <a:buNone/>
+            </a:pPr>
+            <a:r>
+              <a:rPr lang="en-US" sz="1300" b="1" dirty="0">
+                <a:solidFill>
+                  <a:srgbClr val="3FB950"/>
+                </a:solidFill>
+                <a:latin typeface="Calibri" pitchFamily="34" charset="0"/>
+                <a:ea typeface="Calibri" pitchFamily="34" charset="-122"/>
+                <a:cs typeface="Calibri" pitchFamily="34" charset="-120"/>
+              </a:rPr>
+              <a:t>DETALHAMENTO: </a:t>
+            </a:r>
+            <a:pPr indent="0" marL="0">
+              <a:lnSpc>
+                <a:spcPct val="110000"/>
+              </a:lnSpc>
+              <a:buNone/>
+            </a:pPr>
+            <a:r>
+              <a:rPr lang="en-US" sz="1300" dirty="0">
+                <a:solidFill>
+                  <a:srgbClr val="F0F6FC"/>
+                </a:solidFill>
+                <a:latin typeface="Calibri" pitchFamily="34" charset="0"/>
+                <a:ea typeface="Calibri" pitchFamily="34" charset="-122"/>
+                <a:cs typeface="Calibri" pitchFamily="34" charset="-120"/>
+              </a:rPr>
+              <a:t>restringir a publicidade de bets (como já foi feito com o cigarro), criar cadastro nacional de autoexclusão e bloquear o cadastro de menores com verificação real de identidade.</a:t>
+            </a:r>
+            <a:endParaRPr lang="en-US" sz="1300" dirty="0"/>
+          </a:p>
+        </p:txBody>
+      </p:sp>
+    </p:spTree>
+  </p:cSld>
+  <p:clrMapOvr>
+    <a:masterClrMapping/>
+  </p:clrMapOvr>
+</p:sld>
+</file>
+
+<file path=ppt/slides/slide11.xml><?xml version="1.0" encoding="utf-8"?>
+<p:sld xmlns:a="http://schemas.openxmlformats.org/drawingml/2006/main" xmlns:r="http://schemas.openxmlformats.org/officeDocument/2006/relationships" xmlns:p="http://schemas.openxmlformats.org/presentationml/2006/main">
+  <p:cSld name="Slide 11">
+    <p:bg>
+      <p:bgPr>
+        <a:solidFill>
+          <a:srgbClr val="0D1117"/>
+        </a:solidFill>
+      </p:bgPr>
+    </p:bg>
+    <p:spTree>
+      <p:nvGrpSpPr>
+        <p:cNvPr id="1" name=""/>
+        <p:cNvGrpSpPr/>
+        <p:nvPr/>
+      </p:nvGrpSpPr>
+      <p:grpSpPr>
+        <a:xfrm>
+          <a:off x="0" y="0"/>
+          <a:ext cx="0" cy="0"/>
+          <a:chOff x="0" y="0"/>
+          <a:chExt cx="0" cy="0"/>
+        </a:xfrm>
+      </p:grpSpPr>
+      <p:sp>
+        <p:nvSpPr>
+          <p:cNvPr id="2" name="Shape 0"/>
+          <p:cNvSpPr/>
+          <p:nvPr/>
+        </p:nvSpPr>
+        <p:spPr>
+          <a:xfrm>
+            <a:off x="640080" y="457200"/>
+            <a:ext cx="777240" cy="777240"/>
+          </a:xfrm>
+          <a:prstGeom prst="ellipse">
+            <a:avLst/>
+          </a:prstGeom>
+          <a:solidFill>
+            <a:srgbClr val="1C2431"/>
+          </a:solidFill>
+          <a:ln/>
+        </p:spPr>
+      </p:sp>
+      <p:pic>
+        <p:nvPicPr>
+          <p:cNvPr id="3" name="Image 0" descr="preencoded.png">    </p:cNvPr>
+          <p:cNvPicPr>
+            <a:picLocks noChangeAspect="1"/>
+          </p:cNvPicPr>
+          <p:nvPr/>
+        </p:nvPicPr>
+        <p:blipFill>
+          <a:blip r:embed="rId1"/>
+          <a:stretch>
+            <a:fillRect/>
+          </a:stretch>
+        </p:blipFill>
+        <p:spPr>
+          <a:xfrm>
+            <a:off x="842162" y="659282"/>
+            <a:ext cx="373075" cy="373075"/>
+          </a:xfrm>
+          <a:prstGeom prst="rect">
+            <a:avLst/>
+          </a:prstGeom>
+        </p:spPr>
+      </p:pic>
+      <p:sp>
+        <p:nvSpPr>
+          <p:cNvPr id="4" name="Text 1"/>
+          <p:cNvSpPr txBox="1"/>
+          <p:nvPr/>
+        </p:nvSpPr>
+        <p:spPr>
+          <a:xfrm>
+            <a:off x="1645920" y="566928"/>
+            <a:ext cx="6858000" cy="594360"/>
+          </a:xfrm>
+          <a:prstGeom prst="rect">
+            <a:avLst/>
+          </a:prstGeom>
+          <a:noFill/>
+          <a:ln/>
+        </p:spPr>
+        <p:txBody>
+          <a:bodyPr wrap="square" lIns="0" tIns="0" rIns="0" bIns="0" rtlCol="0" anchor="ctr"/>
+          <a:lstStyle/>
+          <a:p>
+            <a:pPr indent="0" marL="0">
+              <a:buNone/>
+            </a:pPr>
+            <a:r>
+              <a:rPr lang="en-US" sz="2600" b="1" dirty="0">
+                <a:solidFill>
+                  <a:srgbClr val="F0F6FC"/>
+                </a:solidFill>
+                <a:latin typeface="Calibri" pitchFamily="34" charset="0"/>
+                <a:ea typeface="Calibri" pitchFamily="34" charset="-122"/>
+                <a:cs typeface="Calibri" pitchFamily="34" charset="-120"/>
+              </a:rPr>
+              <a:t>A CASA NÃO PRECISA VENCER SEMPRE</a:t>
+            </a:r>
+            <a:endParaRPr lang="en-US" sz="2600" dirty="0"/>
+          </a:p>
+        </p:txBody>
+      </p:sp>
+      <p:sp>
+        <p:nvSpPr>
+          <p:cNvPr id="5" name="Text 2"/>
+          <p:cNvSpPr txBox="1"/>
+          <p:nvPr/>
+        </p:nvSpPr>
+        <p:spPr>
+          <a:xfrm>
+            <a:off x="640080" y="1463040"/>
+            <a:ext cx="7863840" cy="1051560"/>
+          </a:xfrm>
+          <a:prstGeom prst="rect">
+            <a:avLst/>
+          </a:prstGeom>
+          <a:noFill/>
+          <a:ln/>
+        </p:spPr>
+        <p:txBody>
+          <a:bodyPr wrap="square" lIns="0" tIns="0" rIns="0" bIns="0" rtlCol="0" anchor="ctr"/>
+          <a:lstStyle/>
+          <a:p>
+            <a:pPr indent="0" marL="0">
+              <a:lnSpc>
+                <a:spcPct val="115000"/>
+              </a:lnSpc>
+              <a:buNone/>
+            </a:pPr>
+            <a:r>
+              <a:rPr lang="en-US" sz="1600" dirty="0">
+                <a:solidFill>
+                  <a:srgbClr val="F0F6FC"/>
+                </a:solidFill>
+                <a:latin typeface="Calibri" pitchFamily="34" charset="0"/>
+                <a:ea typeface="Calibri" pitchFamily="34" charset="-122"/>
+                <a:cs typeface="Calibri" pitchFamily="34" charset="-120"/>
+              </a:rPr>
+              <a:t>Vício em aposta é doença, tem tratamento gratuito no SUS/CAPS e ninguém deve enfrentar isso sozinho. Informação é a melhor aposta: por isso nosso grupo também produziu um vídeo ensinando como identificar e combater o vício em bets.</a:t>
+            </a:r>
+            <a:endParaRPr lang="en-US" sz="1600" dirty="0"/>
+          </a:p>
+        </p:txBody>
+      </p:sp>
+      <p:sp>
+        <p:nvSpPr>
+          <p:cNvPr id="6" name="Shape 3"/>
+          <p:cNvSpPr/>
+          <p:nvPr/>
+        </p:nvSpPr>
+        <p:spPr>
+          <a:xfrm>
+            <a:off x="640080" y="2651760"/>
+            <a:ext cx="3840480" cy="1051560"/>
+          </a:xfrm>
+          <a:prstGeom prst="roundRect">
+            <a:avLst>
+              <a:gd name="adj" fmla="val 8696"/>
+            </a:avLst>
+          </a:prstGeom>
+          <a:solidFill>
+            <a:srgbClr val="161C26"/>
+          </a:solidFill>
+          <a:ln/>
+        </p:spPr>
+      </p:sp>
+      <p:sp>
+        <p:nvSpPr>
+          <p:cNvPr id="7" name="Text 4"/>
+          <p:cNvSpPr txBox="1"/>
+          <p:nvPr/>
+        </p:nvSpPr>
+        <p:spPr>
+          <a:xfrm>
+            <a:off x="822960" y="2743200"/>
+            <a:ext cx="3474720" cy="868680"/>
+          </a:xfrm>
+          <a:prstGeom prst="rect">
+            <a:avLst/>
+          </a:prstGeom>
+          <a:noFill/>
+          <a:ln/>
+        </p:spPr>
+        <p:txBody>
+          <a:bodyPr wrap="square" lIns="0" tIns="0" rIns="0" bIns="0" rtlCol="0" anchor="ctr"/>
+          <a:lstStyle/>
+          <a:p>
+            <a:pPr indent="0" marL="0">
+              <a:lnSpc>
+                <a:spcPct val="110000"/>
+              </a:lnSpc>
+              <a:buNone/>
+            </a:pPr>
+            <a:r>
+              <a:rPr lang="en-US" sz="1300" b="1" dirty="0">
+                <a:solidFill>
+                  <a:srgbClr val="3FB950"/>
+                </a:solidFill>
+                <a:latin typeface="Calibri" pitchFamily="34" charset="0"/>
+                <a:ea typeface="Calibri" pitchFamily="34" charset="-122"/>
+                <a:cs typeface="Calibri" pitchFamily="34" charset="-120"/>
+              </a:rPr>
+              <a:t>ONDE BUSCAR AJUDA
+</a:t>
+            </a:r>
+            <a:pPr indent="0" marL="0">
+              <a:lnSpc>
+                <a:spcPct val="110000"/>
+              </a:lnSpc>
+              <a:buNone/>
+            </a:pPr>
+            <a:r>
+              <a:rPr lang="en-US" sz="1250" dirty="0">
+                <a:solidFill>
+                  <a:srgbClr val="F0F6FC"/>
+                </a:solidFill>
+                <a:latin typeface="Calibri" pitchFamily="34" charset="0"/>
+                <a:ea typeface="Calibri" pitchFamily="34" charset="-122"/>
+                <a:cs typeface="Calibri" pitchFamily="34" charset="-120"/>
+              </a:rPr>
+              <a:t>CAPS (SUS) • Jogadores Anônimos • CVV: ligue 188 (24h, gratuito)</a:t>
+            </a:r>
+            <a:endParaRPr lang="en-US" sz="1300" dirty="0"/>
+          </a:p>
+        </p:txBody>
+      </p:sp>
+      <p:sp>
+        <p:nvSpPr>
+          <p:cNvPr id="8" name="Shape 5"/>
+          <p:cNvSpPr/>
+          <p:nvPr/>
+        </p:nvSpPr>
+        <p:spPr>
+          <a:xfrm>
+            <a:off x="4663440" y="2651760"/>
+            <a:ext cx="3840480" cy="1051560"/>
+          </a:xfrm>
+          <a:prstGeom prst="roundRect">
+            <a:avLst>
+              <a:gd name="adj" fmla="val 8696"/>
+            </a:avLst>
+          </a:prstGeom>
+          <a:solidFill>
+            <a:srgbClr val="161C26"/>
+          </a:solidFill>
+          <a:ln/>
+        </p:spPr>
+      </p:sp>
+      <p:sp>
+        <p:nvSpPr>
+          <p:cNvPr id="9" name="Text 6"/>
+          <p:cNvSpPr txBox="1"/>
+          <p:nvPr/>
+        </p:nvSpPr>
+        <p:spPr>
+          <a:xfrm>
+            <a:off x="4846320" y="2743200"/>
+            <a:ext cx="3474720" cy="868680"/>
+          </a:xfrm>
+          <a:prstGeom prst="rect">
+            <a:avLst/>
+          </a:prstGeom>
+          <a:noFill/>
+          <a:ln/>
+        </p:spPr>
+        <p:txBody>
+          <a:bodyPr wrap="square" lIns="0" tIns="0" rIns="0" bIns="0" rtlCol="0" anchor="ctr"/>
+          <a:lstStyle/>
+          <a:p>
+            <a:pPr indent="0" marL="0">
+              <a:lnSpc>
+                <a:spcPct val="110000"/>
+              </a:lnSpc>
+              <a:buNone/>
+            </a:pPr>
+            <a:r>
+              <a:rPr lang="en-US" sz="1300" b="1" dirty="0">
+                <a:solidFill>
+                  <a:srgbClr val="F85149"/>
+                </a:solidFill>
+                <a:latin typeface="Calibri" pitchFamily="34" charset="0"/>
+                <a:ea typeface="Calibri" pitchFamily="34" charset="-122"/>
+                <a:cs typeface="Calibri" pitchFamily="34" charset="-120"/>
+              </a:rPr>
+              <a:t>SINAIS DE ALERTA
+</a:t>
+            </a:r>
+            <a:pPr indent="0" marL="0">
+              <a:lnSpc>
+                <a:spcPct val="110000"/>
+              </a:lnSpc>
+              <a:buNone/>
+            </a:pPr>
+            <a:r>
+              <a:rPr lang="en-US" sz="1250" dirty="0">
+                <a:solidFill>
+                  <a:srgbClr val="F0F6FC"/>
+                </a:solidFill>
+                <a:latin typeface="Calibri" pitchFamily="34" charset="0"/>
+                <a:ea typeface="Calibri" pitchFamily="34" charset="-122"/>
+                <a:cs typeface="Calibri" pitchFamily="34" charset="-120"/>
+              </a:rPr>
+              <a:t>Apostar escondido • apostar para recuperar perdas • usar dinheiro de contas • irritação ao tentar parar</a:t>
+            </a:r>
+            <a:endParaRPr lang="en-US" sz="1300" dirty="0"/>
+          </a:p>
+        </p:txBody>
+      </p:sp>
+      <p:sp>
+        <p:nvSpPr>
+          <p:cNvPr id="10" name="Text 7"/>
+          <p:cNvSpPr txBox="1"/>
+          <p:nvPr/>
+        </p:nvSpPr>
+        <p:spPr>
+          <a:xfrm>
+            <a:off x="640080" y="4160520"/>
+            <a:ext cx="7863840" cy="640080"/>
+          </a:xfrm>
+          <a:prstGeom prst="rect">
+            <a:avLst/>
+          </a:prstGeom>
+          <a:noFill/>
+          <a:ln/>
+        </p:spPr>
+        <p:txBody>
+          <a:bodyPr wrap="square" lIns="0" tIns="0" rIns="0" bIns="0" rtlCol="0" anchor="ctr"/>
+          <a:lstStyle/>
+          <a:p>
+            <a:pPr indent="0" marL="0">
+              <a:lnSpc>
+                <a:spcPct val="110000"/>
+              </a:lnSpc>
+              <a:buNone/>
+            </a:pPr>
+            <a:r>
+              <a:rPr lang="en-US" sz="1050" dirty="0">
+                <a:solidFill>
+                  <a:srgbClr val="9BA7B4"/>
+                </a:solidFill>
+                <a:latin typeface="Calibri" pitchFamily="34" charset="0"/>
+                <a:ea typeface="Calibri" pitchFamily="34" charset="-122"/>
+                <a:cs typeface="Calibri" pitchFamily="34" charset="-120"/>
+              </a:rPr>
+              <a:t>Fontes: Fiocruz (Radis) • Agência Brasil / Ministério da Saúde • Associação Brasileira de Psiquiatria • Banco Central • FIA Business School / Ibevar • Associação Médica Brasileira</a:t>
+            </a:r>
+            <a:endParaRPr lang="en-US" sz="1050" dirty="0"/>
           </a:p>
         </p:txBody>
       </p:sp>
@@ -3465,7 +5707,46 @@
         </p:nvSpPr>
         <p:spPr>
           <a:xfrm>
-            <a:off x="640080" y="365760"/>
+            <a:off x="640080" y="384048"/>
+            <a:ext cx="2743200" cy="365760"/>
+          </a:xfrm>
+          <a:prstGeom prst="rect">
+            <a:avLst/>
+          </a:prstGeom>
+          <a:noFill/>
+          <a:ln/>
+        </p:spPr>
+        <p:txBody>
+          <a:bodyPr wrap="square" lIns="0" tIns="0" rIns="0" bIns="0" rtlCol="0" anchor="ctr"/>
+          <a:lstStyle/>
+          <a:p>
+            <a:pPr indent="0" marL="0">
+              <a:buNone/>
+            </a:pPr>
+            <a:r>
+              <a:rPr lang="en-US" sz="1500" b="1" spc="400" kern="0" dirty="0">
+                <a:solidFill>
+                  <a:srgbClr val="E3B341"/>
+                </a:solidFill>
+                <a:latin typeface="Calibri" pitchFamily="34" charset="0"/>
+                <a:ea typeface="Calibri" pitchFamily="34" charset="-122"/>
+                <a:cs typeface="Calibri" pitchFamily="34" charset="-120"/>
+              </a:rPr>
+              <a:t>MATEMÁTICA</a:t>
+            </a:r>
+            <a:endParaRPr lang="en-US" sz="1500" dirty="0"/>
+          </a:p>
+        </p:txBody>
+      </p:sp>
+      <p:sp>
+        <p:nvSpPr>
+          <p:cNvPr id="3" name="Text 1"/>
+          <p:cNvSpPr txBox="1"/>
+          <p:nvPr/>
+        </p:nvSpPr>
+        <p:spPr>
+          <a:xfrm>
+            <a:off x="640080" y="749808"/>
             <a:ext cx="7863840" cy="548640"/>
           </a:xfrm>
           <a:prstGeom prst="rect">
@@ -3482,7 +5763,7 @@
               <a:buNone/>
             </a:pPr>
             <a:r>
-              <a:rPr lang="en-US" sz="3000" b="1" dirty="0">
+              <a:rPr lang="en-US" sz="2900" b="1" dirty="0">
                 <a:solidFill>
                   <a:srgbClr val="F0F6FC"/>
                 </a:solidFill>
@@ -3490,26 +5771,26 @@
                 <a:ea typeface="Calibri" pitchFamily="34" charset="-122"/>
                 <a:cs typeface="Calibri" pitchFamily="34" charset="-120"/>
               </a:rPr>
-              <a:t>PROPOSTA DE INTERVENÇÃO</a:t>
-            </a:r>
-            <a:endParaRPr lang="en-US" sz="3000" dirty="0"/>
-          </a:p>
-        </p:txBody>
-      </p:sp>
-      <p:sp>
-        <p:nvSpPr>
-          <p:cNvPr id="3" name="Shape 1"/>
+              <a:t>Por que a casa sempre vence</a:t>
+            </a:r>
+            <a:endParaRPr lang="en-US" sz="2900" dirty="0"/>
+          </a:p>
+        </p:txBody>
+      </p:sp>
+      <p:sp>
+        <p:nvSpPr>
+          <p:cNvPr id="4" name="Shape 2"/>
           <p:cNvSpPr/>
           <p:nvPr/>
         </p:nvSpPr>
         <p:spPr>
           <a:xfrm>
-            <a:off x="640080" y="1143000"/>
-            <a:ext cx="1938528" cy="2331720"/>
+            <a:off x="640080" y="1463040"/>
+            <a:ext cx="3246120" cy="3200400"/>
           </a:xfrm>
           <a:prstGeom prst="roundRect">
             <a:avLst>
-              <a:gd name="adj" fmla="val 4717"/>
+              <a:gd name="adj" fmla="val 3429"/>
             </a:avLst>
           </a:prstGeom>
           <a:solidFill>
@@ -3520,58 +5801,14 @@
       </p:sp>
       <p:sp>
         <p:nvSpPr>
-          <p:cNvPr id="4" name="Shape 2"/>
-          <p:cNvSpPr/>
-          <p:nvPr/>
-        </p:nvSpPr>
-        <p:spPr>
-          <a:xfrm>
-            <a:off x="804672" y="1307592"/>
-            <a:ext cx="502920" cy="502920"/>
-          </a:xfrm>
-          <a:prstGeom prst="ellipse">
-            <a:avLst/>
-          </a:prstGeom>
-          <a:solidFill>
-            <a:srgbClr val="1C2431"/>
-          </a:solidFill>
-          <a:ln/>
-        </p:spPr>
-      </p:sp>
-      <p:pic>
-        <p:nvPicPr>
-          <p:cNvPr id="5" name="Image 0" descr="preencoded.png">    </p:cNvPr>
-          <p:cNvPicPr>
-            <a:picLocks noChangeAspect="1"/>
-          </p:cNvPicPr>
-          <p:nvPr/>
-        </p:nvPicPr>
-        <p:blipFill>
-          <a:blip r:embed="rId1"/>
-          <a:stretch>
-            <a:fillRect/>
-          </a:stretch>
-        </p:blipFill>
-        <p:spPr>
-          <a:xfrm>
-            <a:off x="935431" y="1438351"/>
-            <a:ext cx="241402" cy="241402"/>
-          </a:xfrm>
-          <a:prstGeom prst="rect">
-            <a:avLst/>
-          </a:prstGeom>
-        </p:spPr>
-      </p:pic>
-      <p:sp>
-        <p:nvSpPr>
-          <p:cNvPr id="6" name="Text 3"/>
+          <p:cNvPr id="5" name="Text 3"/>
           <p:cNvSpPr txBox="1"/>
           <p:nvPr/>
         </p:nvSpPr>
         <p:spPr>
           <a:xfrm>
-            <a:off x="804672" y="1920240"/>
-            <a:ext cx="1609344" cy="320040"/>
+            <a:off x="868680" y="1691640"/>
+            <a:ext cx="2788920" cy="2788920"/>
           </a:xfrm>
           <a:prstGeom prst="rect">
             <a:avLst/>
@@ -3580,27 +5817,154 @@
           <a:ln/>
         </p:spPr>
         <p:txBody>
-          <a:bodyPr wrap="square" lIns="0" tIns="0" rIns="0" bIns="0" rtlCol="0" anchor="ctr"/>
+          <a:bodyPr wrap="square" lIns="0" tIns="0" rIns="0" bIns="0" rtlCol="0" anchor="t"/>
           <a:lstStyle/>
           <a:p>
             <a:pPr indent="0" marL="0">
-              <a:buNone/>
-            </a:pPr>
-            <a:r>
-              <a:rPr lang="en-US" sz="1400" b="1" dirty="0">
-                <a:solidFill>
-                  <a:srgbClr val="3FB950"/>
-                </a:solidFill>
-                <a:latin typeface="Calibri" pitchFamily="34" charset="0"/>
-                <a:ea typeface="Calibri" pitchFamily="34" charset="-122"/>
-                <a:cs typeface="Calibri" pitchFamily="34" charset="-120"/>
-              </a:rPr>
-              <a:t>AGENTE</a:t>
-            </a:r>
-            <a:endParaRPr lang="en-US" sz="1400" dirty="0"/>
-          </a:p>
-        </p:txBody>
-      </p:sp>
+              <a:lnSpc>
+                <a:spcPct val="112000"/>
+              </a:lnSpc>
+              <a:buNone/>
+            </a:pPr>
+            <a:r>
+              <a:rPr lang="en-US" sz="1300" b="1" dirty="0">
+                <a:solidFill>
+                  <a:srgbClr val="E3B341"/>
+                </a:solidFill>
+                <a:latin typeface="Calibri" pitchFamily="34" charset="0"/>
+                <a:ea typeface="Calibri" pitchFamily="34" charset="-122"/>
+                <a:cs typeface="Calibri" pitchFamily="34" charset="-120"/>
+              </a:rPr>
+              <a:t>VALOR ESPERADO
+</a:t>
+            </a:r>
+            <a:pPr indent="0" marL="0">
+              <a:lnSpc>
+                <a:spcPct val="112000"/>
+              </a:lnSpc>
+              <a:buNone/>
+            </a:pPr>
+            <a:r>
+              <a:rPr lang="en-US" sz="1300" dirty="0">
+                <a:solidFill>
+                  <a:srgbClr val="F0F6FC"/>
+                </a:solidFill>
+                <a:latin typeface="Calibri" pitchFamily="34" charset="0"/>
+                <a:ea typeface="Calibri" pitchFamily="34" charset="-122"/>
+                <a:cs typeface="Calibri" pitchFamily="34" charset="-120"/>
+              </a:rPr>
+              <a:t>O 'jogo do tigrinho' devolve, em média, 96,8% do que recebe (RTP divulgado).
+</a:t>
+            </a:r>
+            <a:pPr indent="0" marL="0">
+              <a:lnSpc>
+                <a:spcPct val="112000"/>
+              </a:lnSpc>
+              <a:buNone/>
+            </a:pPr>
+            <a:r>
+              <a:rPr lang="en-US" sz="1300" dirty="0">
+                <a:solidFill>
+                  <a:srgbClr val="F0F6FC"/>
+                </a:solidFill>
+                <a:latin typeface="Calibri" pitchFamily="34" charset="0"/>
+                <a:ea typeface="Calibri" pitchFamily="34" charset="-122"/>
+                <a:cs typeface="Calibri" pitchFamily="34" charset="-120"/>
+              </a:rPr>
+              <a:t>A cada R$ 100 apostados:
+</a:t>
+            </a:r>
+            <a:pPr indent="0" marL="0">
+              <a:lnSpc>
+                <a:spcPct val="112000"/>
+              </a:lnSpc>
+              <a:buNone/>
+            </a:pPr>
+            <a:r>
+              <a:rPr lang="en-US" sz="1350" b="1" dirty="0">
+                <a:solidFill>
+                  <a:srgbClr val="F0F6FC"/>
+                </a:solidFill>
+                <a:latin typeface="Calibri" pitchFamily="34" charset="0"/>
+                <a:ea typeface="Calibri" pitchFamily="34" charset="-122"/>
+                <a:cs typeface="Calibri" pitchFamily="34" charset="-120"/>
+              </a:rPr>
+              <a:t>E = 100 × 0,968 = R$ 96,80
+</a:t>
+            </a:r>
+            <a:pPr indent="0" marL="0">
+              <a:lnSpc>
+                <a:spcPct val="112000"/>
+              </a:lnSpc>
+              <a:buNone/>
+            </a:pPr>
+            <a:r>
+              <a:rPr lang="en-US" sz="1300" b="1" dirty="0">
+                <a:solidFill>
+                  <a:srgbClr val="F85149"/>
+                </a:solidFill>
+                <a:latin typeface="Calibri" pitchFamily="34" charset="0"/>
+                <a:ea typeface="Calibri" pitchFamily="34" charset="-122"/>
+                <a:cs typeface="Calibri" pitchFamily="34" charset="-120"/>
+              </a:rPr>
+              <a:t>Perda média: R$ 3,20 por rodada
+</a:t>
+            </a:r>
+            <a:pPr indent="0" marL="0">
+              <a:lnSpc>
+                <a:spcPct val="112000"/>
+              </a:lnSpc>
+              <a:buNone/>
+            </a:pPr>
+            <a:r>
+              <a:rPr lang="en-US" sz="1300" dirty="0">
+                <a:solidFill>
+                  <a:srgbClr val="F0F6FC"/>
+                </a:solidFill>
+                <a:latin typeface="Calibri" pitchFamily="34" charset="0"/>
+                <a:ea typeface="Calibri" pitchFamily="34" charset="-122"/>
+                <a:cs typeface="Calibri" pitchFamily="34" charset="-120"/>
+              </a:rPr>
+              <a:t>Reapostando tudo n vezes:
+</a:t>
+            </a:r>
+            <a:pPr indent="0" marL="0">
+              <a:lnSpc>
+                <a:spcPct val="112000"/>
+              </a:lnSpc>
+              <a:buNone/>
+            </a:pPr>
+            <a:r>
+              <a:rPr lang="en-US" sz="1500" b="1" dirty="0">
+                <a:solidFill>
+                  <a:srgbClr val="F0F6FC"/>
+                </a:solidFill>
+                <a:latin typeface="Calibri" pitchFamily="34" charset="0"/>
+                <a:ea typeface="Calibri" pitchFamily="34" charset="-122"/>
+                <a:cs typeface="Calibri" pitchFamily="34" charset="-120"/>
+              </a:rPr>
+              <a:t>E(n) = 100 × 0,968ⁿ</a:t>
+            </a:r>
+            <a:endParaRPr lang="en-US" sz="1300" dirty="0"/>
+          </a:p>
+        </p:txBody>
+      </p:sp>
+      <p:graphicFrame>
+        <p:nvGraphicFramePr>
+          <p:cNvPr id="6" name="Chart 0" descr=""/>
+          <p:cNvGraphicFramePr/>
+          <p:nvPr/>
+        </p:nvGraphicFramePr>
+        <p:xfrm>
+          <a:off x="4114800" y="1417320"/>
+          <a:ext cx="4480560" cy="3063240"/>
+        </p:xfrm>
+        <a:graphic xmlns:a="http://schemas.openxmlformats.org/drawingml/2006/main">
+          <a:graphicData uri="http://schemas.openxmlformats.org/drawingml/2006/chart">
+            <c:chart xmlns:c="http://schemas.openxmlformats.org/drawingml/2006/chart" r:id="rId1"/>
+          </a:graphicData>
+        </a:graphic>
+      </p:graphicFrame>
       <p:sp>
         <p:nvSpPr>
           <p:cNvPr id="7" name="Text 4"/>
@@ -3609,8 +5973,8 @@
         </p:nvSpPr>
         <p:spPr>
           <a:xfrm>
-            <a:off x="804672" y="2240280"/>
-            <a:ext cx="1609344" cy="1097280"/>
+            <a:off x="4114800" y="4480560"/>
+            <a:ext cx="4480560" cy="365760"/>
           </a:xfrm>
           <a:prstGeom prst="rect">
             <a:avLst/>
@@ -3619,593 +5983,24 @@
           <a:ln/>
         </p:spPr>
         <p:txBody>
-          <a:bodyPr wrap="square" lIns="0" tIns="0" rIns="0" bIns="0" rtlCol="0" anchor="t"/>
+          <a:bodyPr wrap="square" lIns="0" tIns="0" rIns="0" bIns="0" rtlCol="0" anchor="ctr"/>
           <a:lstStyle/>
           <a:p>
             <a:pPr indent="0" marL="0">
-              <a:lnSpc>
-                <a:spcPct val="110000"/>
-              </a:lnSpc>
-              <a:buNone/>
-            </a:pPr>
-            <a:r>
-              <a:rPr lang="en-US" sz="1150" dirty="0">
-                <a:solidFill>
-                  <a:srgbClr val="F0F6FC"/>
-                </a:solidFill>
-                <a:latin typeface="Calibri" pitchFamily="34" charset="0"/>
-                <a:ea typeface="Calibri" pitchFamily="34" charset="-122"/>
-                <a:cs typeface="Calibri" pitchFamily="34" charset="-120"/>
-              </a:rPr>
-              <a:t>Ministério da Saúde e escolas, em parceria com as prefeituras</a:t>
+              <a:buNone/>
+            </a:pPr>
+            <a:r>
+              <a:rPr lang="en-US" sz="1150" i="1" dirty="0">
+                <a:solidFill>
+                  <a:srgbClr val="9BA7B4"/>
+                </a:solidFill>
+                <a:latin typeface="Calibri" pitchFamily="34" charset="0"/>
+                <a:ea typeface="Calibri" pitchFamily="34" charset="-122"/>
+                <a:cs typeface="Calibri" pitchFamily="34" charset="-120"/>
+              </a:rPr>
+              <a:t>Não é azar: é uma função exponencial decrescente. Jogando o suficiente, a perda é matemática.</a:t>
             </a:r>
             <a:endParaRPr lang="en-US" sz="1150" dirty="0"/>
-          </a:p>
-        </p:txBody>
-      </p:sp>
-      <p:sp>
-        <p:nvSpPr>
-          <p:cNvPr id="8" name="Shape 5"/>
-          <p:cNvSpPr/>
-          <p:nvPr/>
-        </p:nvSpPr>
-        <p:spPr>
-          <a:xfrm>
-            <a:off x="2779776" y="1143000"/>
-            <a:ext cx="1938528" cy="2331720"/>
-          </a:xfrm>
-          <a:prstGeom prst="roundRect">
-            <a:avLst>
-              <a:gd name="adj" fmla="val 4717"/>
-            </a:avLst>
-          </a:prstGeom>
-          <a:solidFill>
-            <a:srgbClr val="161C26"/>
-          </a:solidFill>
-          <a:ln/>
-        </p:spPr>
-      </p:sp>
-      <p:sp>
-        <p:nvSpPr>
-          <p:cNvPr id="9" name="Shape 6"/>
-          <p:cNvSpPr/>
-          <p:nvPr/>
-        </p:nvSpPr>
-        <p:spPr>
-          <a:xfrm>
-            <a:off x="2944368" y="1307592"/>
-            <a:ext cx="502920" cy="502920"/>
-          </a:xfrm>
-          <a:prstGeom prst="ellipse">
-            <a:avLst/>
-          </a:prstGeom>
-          <a:solidFill>
-            <a:srgbClr val="1C2431"/>
-          </a:solidFill>
-          <a:ln/>
-        </p:spPr>
-      </p:sp>
-      <p:pic>
-        <p:nvPicPr>
-          <p:cNvPr id="10" name="Image 1" descr="preencoded.png">    </p:cNvPr>
-          <p:cNvPicPr>
-            <a:picLocks noChangeAspect="1"/>
-          </p:cNvPicPr>
-          <p:nvPr/>
-        </p:nvPicPr>
-        <p:blipFill>
-          <a:blip r:embed="rId2"/>
-          <a:stretch>
-            <a:fillRect/>
-          </a:stretch>
-        </p:blipFill>
-        <p:spPr>
-          <a:xfrm>
-            <a:off x="3075127" y="1438351"/>
-            <a:ext cx="241402" cy="241402"/>
-          </a:xfrm>
-          <a:prstGeom prst="rect">
-            <a:avLst/>
-          </a:prstGeom>
-        </p:spPr>
-      </p:pic>
-      <p:sp>
-        <p:nvSpPr>
-          <p:cNvPr id="11" name="Text 7"/>
-          <p:cNvSpPr txBox="1"/>
-          <p:nvPr/>
-        </p:nvSpPr>
-        <p:spPr>
-          <a:xfrm>
-            <a:off x="2944368" y="1920240"/>
-            <a:ext cx="1609344" cy="320040"/>
-          </a:xfrm>
-          <a:prstGeom prst="rect">
-            <a:avLst/>
-          </a:prstGeom>
-          <a:noFill/>
-          <a:ln/>
-        </p:spPr>
-        <p:txBody>
-          <a:bodyPr wrap="square" lIns="0" tIns="0" rIns="0" bIns="0" rtlCol="0" anchor="ctr"/>
-          <a:lstStyle/>
-          <a:p>
-            <a:pPr indent="0" marL="0">
-              <a:buNone/>
-            </a:pPr>
-            <a:r>
-              <a:rPr lang="en-US" sz="1400" b="1" dirty="0">
-                <a:solidFill>
-                  <a:srgbClr val="3FB950"/>
-                </a:solidFill>
-                <a:latin typeface="Calibri" pitchFamily="34" charset="0"/>
-                <a:ea typeface="Calibri" pitchFamily="34" charset="-122"/>
-                <a:cs typeface="Calibri" pitchFamily="34" charset="-120"/>
-              </a:rPr>
-              <a:t>AÇÃO</a:t>
-            </a:r>
-            <a:endParaRPr lang="en-US" sz="1400" dirty="0"/>
-          </a:p>
-        </p:txBody>
-      </p:sp>
-      <p:sp>
-        <p:nvSpPr>
-          <p:cNvPr id="12" name="Text 8"/>
-          <p:cNvSpPr txBox="1"/>
-          <p:nvPr/>
-        </p:nvSpPr>
-        <p:spPr>
-          <a:xfrm>
-            <a:off x="2944368" y="2240280"/>
-            <a:ext cx="1609344" cy="1097280"/>
-          </a:xfrm>
-          <a:prstGeom prst="rect">
-            <a:avLst/>
-          </a:prstGeom>
-          <a:noFill/>
-          <a:ln/>
-        </p:spPr>
-        <p:txBody>
-          <a:bodyPr wrap="square" lIns="0" tIns="0" rIns="0" bIns="0" rtlCol="0" anchor="t"/>
-          <a:lstStyle/>
-          <a:p>
-            <a:pPr indent="0" marL="0">
-              <a:lnSpc>
-                <a:spcPct val="110000"/>
-              </a:lnSpc>
-              <a:buNone/>
-            </a:pPr>
-            <a:r>
-              <a:rPr lang="en-US" sz="1150" dirty="0">
-                <a:solidFill>
-                  <a:srgbClr val="F0F6FC"/>
-                </a:solidFill>
-                <a:latin typeface="Calibri" pitchFamily="34" charset="0"/>
-                <a:ea typeface="Calibri" pitchFamily="34" charset="-122"/>
-                <a:cs typeface="Calibri" pitchFamily="34" charset="-120"/>
-              </a:rPr>
-              <a:t>Campanha nacional de conscientização + ampliação do tratamento gratuito nos CAPS/SUS</a:t>
-            </a:r>
-            <a:endParaRPr lang="en-US" sz="1150" dirty="0"/>
-          </a:p>
-        </p:txBody>
-      </p:sp>
-      <p:sp>
-        <p:nvSpPr>
-          <p:cNvPr id="13" name="Shape 9"/>
-          <p:cNvSpPr/>
-          <p:nvPr/>
-        </p:nvSpPr>
-        <p:spPr>
-          <a:xfrm>
-            <a:off x="4919472" y="1143000"/>
-            <a:ext cx="1938528" cy="2331720"/>
-          </a:xfrm>
-          <a:prstGeom prst="roundRect">
-            <a:avLst>
-              <a:gd name="adj" fmla="val 4717"/>
-            </a:avLst>
-          </a:prstGeom>
-          <a:solidFill>
-            <a:srgbClr val="161C26"/>
-          </a:solidFill>
-          <a:ln/>
-        </p:spPr>
-      </p:sp>
-      <p:sp>
-        <p:nvSpPr>
-          <p:cNvPr id="14" name="Shape 10"/>
-          <p:cNvSpPr/>
-          <p:nvPr/>
-        </p:nvSpPr>
-        <p:spPr>
-          <a:xfrm>
-            <a:off x="5084064" y="1307592"/>
-            <a:ext cx="502920" cy="502920"/>
-          </a:xfrm>
-          <a:prstGeom prst="ellipse">
-            <a:avLst/>
-          </a:prstGeom>
-          <a:solidFill>
-            <a:srgbClr val="1C2431"/>
-          </a:solidFill>
-          <a:ln/>
-        </p:spPr>
-      </p:sp>
-      <p:pic>
-        <p:nvPicPr>
-          <p:cNvPr id="15" name="Image 2" descr="preencoded.png">    </p:cNvPr>
-          <p:cNvPicPr>
-            <a:picLocks noChangeAspect="1"/>
-          </p:cNvPicPr>
-          <p:nvPr/>
-        </p:nvPicPr>
-        <p:blipFill>
-          <a:blip r:embed="rId3"/>
-          <a:stretch>
-            <a:fillRect/>
-          </a:stretch>
-        </p:blipFill>
-        <p:spPr>
-          <a:xfrm>
-            <a:off x="5214823" y="1438351"/>
-            <a:ext cx="241402" cy="241402"/>
-          </a:xfrm>
-          <a:prstGeom prst="rect">
-            <a:avLst/>
-          </a:prstGeom>
-        </p:spPr>
-      </p:pic>
-      <p:sp>
-        <p:nvSpPr>
-          <p:cNvPr id="16" name="Text 11"/>
-          <p:cNvSpPr txBox="1"/>
-          <p:nvPr/>
-        </p:nvSpPr>
-        <p:spPr>
-          <a:xfrm>
-            <a:off x="5084064" y="1920240"/>
-            <a:ext cx="1609344" cy="320040"/>
-          </a:xfrm>
-          <a:prstGeom prst="rect">
-            <a:avLst/>
-          </a:prstGeom>
-          <a:noFill/>
-          <a:ln/>
-        </p:spPr>
-        <p:txBody>
-          <a:bodyPr wrap="square" lIns="0" tIns="0" rIns="0" bIns="0" rtlCol="0" anchor="ctr"/>
-          <a:lstStyle/>
-          <a:p>
-            <a:pPr indent="0" marL="0">
-              <a:buNone/>
-            </a:pPr>
-            <a:r>
-              <a:rPr lang="en-US" sz="1400" b="1" dirty="0">
-                <a:solidFill>
-                  <a:srgbClr val="3FB950"/>
-                </a:solidFill>
-                <a:latin typeface="Calibri" pitchFamily="34" charset="0"/>
-                <a:ea typeface="Calibri" pitchFamily="34" charset="-122"/>
-                <a:cs typeface="Calibri" pitchFamily="34" charset="-120"/>
-              </a:rPr>
-              <a:t>MEIO</a:t>
-            </a:r>
-            <a:endParaRPr lang="en-US" sz="1400" dirty="0"/>
-          </a:p>
-        </p:txBody>
-      </p:sp>
-      <p:sp>
-        <p:nvSpPr>
-          <p:cNvPr id="17" name="Text 12"/>
-          <p:cNvSpPr txBox="1"/>
-          <p:nvPr/>
-        </p:nvSpPr>
-        <p:spPr>
-          <a:xfrm>
-            <a:off x="5084064" y="2240280"/>
-            <a:ext cx="1609344" cy="1097280"/>
-          </a:xfrm>
-          <a:prstGeom prst="rect">
-            <a:avLst/>
-          </a:prstGeom>
-          <a:noFill/>
-          <a:ln/>
-        </p:spPr>
-        <p:txBody>
-          <a:bodyPr wrap="square" lIns="0" tIns="0" rIns="0" bIns="0" rtlCol="0" anchor="t"/>
-          <a:lstStyle/>
-          <a:p>
-            <a:pPr indent="0" marL="0">
-              <a:lnSpc>
-                <a:spcPct val="110000"/>
-              </a:lnSpc>
-              <a:buNone/>
-            </a:pPr>
-            <a:r>
-              <a:rPr lang="en-US" sz="1150" dirty="0">
-                <a:solidFill>
-                  <a:srgbClr val="F0F6FC"/>
-                </a:solidFill>
-                <a:latin typeface="Calibri" pitchFamily="34" charset="0"/>
-                <a:ea typeface="Calibri" pitchFamily="34" charset="-122"/>
-                <a:cs typeface="Calibri" pitchFamily="34" charset="-120"/>
-              </a:rPr>
-              <a:t>Vídeos informativos nas redes sociais, palestras nas escolas e divulgação dos canais de ajuda</a:t>
-            </a:r>
-            <a:endParaRPr lang="en-US" sz="1150" dirty="0"/>
-          </a:p>
-        </p:txBody>
-      </p:sp>
-      <p:sp>
-        <p:nvSpPr>
-          <p:cNvPr id="18" name="Shape 13"/>
-          <p:cNvSpPr/>
-          <p:nvPr/>
-        </p:nvSpPr>
-        <p:spPr>
-          <a:xfrm>
-            <a:off x="7059168" y="1143000"/>
-            <a:ext cx="1938528" cy="2331720"/>
-          </a:xfrm>
-          <a:prstGeom prst="roundRect">
-            <a:avLst>
-              <a:gd name="adj" fmla="val 4717"/>
-            </a:avLst>
-          </a:prstGeom>
-          <a:solidFill>
-            <a:srgbClr val="161C26"/>
-          </a:solidFill>
-          <a:ln/>
-        </p:spPr>
-      </p:sp>
-      <p:sp>
-        <p:nvSpPr>
-          <p:cNvPr id="19" name="Shape 14"/>
-          <p:cNvSpPr/>
-          <p:nvPr/>
-        </p:nvSpPr>
-        <p:spPr>
-          <a:xfrm>
-            <a:off x="7223760" y="1307592"/>
-            <a:ext cx="502920" cy="502920"/>
-          </a:xfrm>
-          <a:prstGeom prst="ellipse">
-            <a:avLst/>
-          </a:prstGeom>
-          <a:solidFill>
-            <a:srgbClr val="1C2431"/>
-          </a:solidFill>
-          <a:ln/>
-        </p:spPr>
-      </p:sp>
-      <p:pic>
-        <p:nvPicPr>
-          <p:cNvPr id="20" name="Image 3" descr="preencoded.png">    </p:cNvPr>
-          <p:cNvPicPr>
-            <a:picLocks noChangeAspect="1"/>
-          </p:cNvPicPr>
-          <p:nvPr/>
-        </p:nvPicPr>
-        <p:blipFill>
-          <a:blip r:embed="rId4"/>
-          <a:stretch>
-            <a:fillRect/>
-          </a:stretch>
-        </p:blipFill>
-        <p:spPr>
-          <a:xfrm>
-            <a:off x="7354519" y="1438351"/>
-            <a:ext cx="241402" cy="241402"/>
-          </a:xfrm>
-          <a:prstGeom prst="rect">
-            <a:avLst/>
-          </a:prstGeom>
-        </p:spPr>
-      </p:pic>
-      <p:sp>
-        <p:nvSpPr>
-          <p:cNvPr id="21" name="Text 15"/>
-          <p:cNvSpPr txBox="1"/>
-          <p:nvPr/>
-        </p:nvSpPr>
-        <p:spPr>
-          <a:xfrm>
-            <a:off x="7223760" y="1920240"/>
-            <a:ext cx="1609344" cy="320040"/>
-          </a:xfrm>
-          <a:prstGeom prst="rect">
-            <a:avLst/>
-          </a:prstGeom>
-          <a:noFill/>
-          <a:ln/>
-        </p:spPr>
-        <p:txBody>
-          <a:bodyPr wrap="square" lIns="0" tIns="0" rIns="0" bIns="0" rtlCol="0" anchor="ctr"/>
-          <a:lstStyle/>
-          <a:p>
-            <a:pPr indent="0" marL="0">
-              <a:buNone/>
-            </a:pPr>
-            <a:r>
-              <a:rPr lang="en-US" sz="1400" b="1" dirty="0">
-                <a:solidFill>
-                  <a:srgbClr val="3FB950"/>
-                </a:solidFill>
-                <a:latin typeface="Calibri" pitchFamily="34" charset="0"/>
-                <a:ea typeface="Calibri" pitchFamily="34" charset="-122"/>
-                <a:cs typeface="Calibri" pitchFamily="34" charset="-120"/>
-              </a:rPr>
-              <a:t>FINALIDADE</a:t>
-            </a:r>
-            <a:endParaRPr lang="en-US" sz="1400" dirty="0"/>
-          </a:p>
-        </p:txBody>
-      </p:sp>
-      <p:sp>
-        <p:nvSpPr>
-          <p:cNvPr id="22" name="Text 16"/>
-          <p:cNvSpPr txBox="1"/>
-          <p:nvPr/>
-        </p:nvSpPr>
-        <p:spPr>
-          <a:xfrm>
-            <a:off x="7223760" y="2240280"/>
-            <a:ext cx="1609344" cy="1097280"/>
-          </a:xfrm>
-          <a:prstGeom prst="rect">
-            <a:avLst/>
-          </a:prstGeom>
-          <a:noFill/>
-          <a:ln/>
-        </p:spPr>
-        <p:txBody>
-          <a:bodyPr wrap="square" lIns="0" tIns="0" rIns="0" bIns="0" rtlCol="0" anchor="t"/>
-          <a:lstStyle/>
-          <a:p>
-            <a:pPr indent="0" marL="0">
-              <a:lnSpc>
-                <a:spcPct val="110000"/>
-              </a:lnSpc>
-              <a:buNone/>
-            </a:pPr>
-            <a:r>
-              <a:rPr lang="en-US" sz="1150" dirty="0">
-                <a:solidFill>
-                  <a:srgbClr val="F0F6FC"/>
-                </a:solidFill>
-                <a:latin typeface="Calibri" pitchFamily="34" charset="0"/>
-                <a:ea typeface="Calibri" pitchFamily="34" charset="-122"/>
-                <a:cs typeface="Calibri" pitchFamily="34" charset="-120"/>
-              </a:rPr>
-              <a:t>Reduzir o número de viciados e proteger os jovens antes da primeira aposta</a:t>
-            </a:r>
-            <a:endParaRPr lang="en-US" sz="1150" dirty="0"/>
-          </a:p>
-        </p:txBody>
-      </p:sp>
-      <p:sp>
-        <p:nvSpPr>
-          <p:cNvPr id="23" name="Shape 17"/>
-          <p:cNvSpPr/>
-          <p:nvPr/>
-        </p:nvSpPr>
-        <p:spPr>
-          <a:xfrm>
-            <a:off x="640080" y="3703320"/>
-            <a:ext cx="7863840" cy="1005840"/>
-          </a:xfrm>
-          <a:prstGeom prst="roundRect">
-            <a:avLst>
-              <a:gd name="adj" fmla="val 9091"/>
-            </a:avLst>
-          </a:prstGeom>
-          <a:solidFill>
-            <a:srgbClr val="1C2431"/>
-          </a:solidFill>
-          <a:ln/>
-        </p:spPr>
-      </p:sp>
-      <p:sp>
-        <p:nvSpPr>
-          <p:cNvPr id="24" name="Shape 18"/>
-          <p:cNvSpPr/>
-          <p:nvPr/>
-        </p:nvSpPr>
-        <p:spPr>
-          <a:xfrm>
-            <a:off x="822960" y="3950208"/>
-            <a:ext cx="502920" cy="502920"/>
-          </a:xfrm>
-          <a:prstGeom prst="ellipse">
-            <a:avLst/>
-          </a:prstGeom>
-          <a:solidFill>
-            <a:srgbClr val="161C26"/>
-          </a:solidFill>
-          <a:ln/>
-        </p:spPr>
-      </p:sp>
-      <p:pic>
-        <p:nvPicPr>
-          <p:cNvPr id="25" name="Image 4" descr="preencoded.png">    </p:cNvPr>
-          <p:cNvPicPr>
-            <a:picLocks noChangeAspect="1"/>
-          </p:cNvPicPr>
-          <p:nvPr/>
-        </p:nvPicPr>
-        <p:blipFill>
-          <a:blip r:embed="rId5"/>
-          <a:stretch>
-            <a:fillRect/>
-          </a:stretch>
-        </p:blipFill>
-        <p:spPr>
-          <a:xfrm>
-            <a:off x="953719" y="4080967"/>
-            <a:ext cx="241402" cy="241402"/>
-          </a:xfrm>
-          <a:prstGeom prst="rect">
-            <a:avLst/>
-          </a:prstGeom>
-        </p:spPr>
-      </p:pic>
-      <p:sp>
-        <p:nvSpPr>
-          <p:cNvPr id="26" name="Text 19"/>
-          <p:cNvSpPr txBox="1"/>
-          <p:nvPr/>
-        </p:nvSpPr>
-        <p:spPr>
-          <a:xfrm>
-            <a:off x="1508760" y="3794760"/>
-            <a:ext cx="6812280" cy="822960"/>
-          </a:xfrm>
-          <a:prstGeom prst="rect">
-            <a:avLst/>
-          </a:prstGeom>
-          <a:noFill/>
-          <a:ln/>
-        </p:spPr>
-        <p:txBody>
-          <a:bodyPr wrap="square" lIns="0" tIns="0" rIns="0" bIns="0" rtlCol="0" anchor="ctr"/>
-          <a:lstStyle/>
-          <a:p>
-            <a:pPr indent="0" marL="0">
-              <a:lnSpc>
-                <a:spcPct val="110000"/>
-              </a:lnSpc>
-              <a:buNone/>
-            </a:pPr>
-            <a:r>
-              <a:rPr lang="en-US" sz="1300" b="1" dirty="0">
-                <a:solidFill>
-                  <a:srgbClr val="3FB950"/>
-                </a:solidFill>
-                <a:latin typeface="Calibri" pitchFamily="34" charset="0"/>
-                <a:ea typeface="Calibri" pitchFamily="34" charset="-122"/>
-                <a:cs typeface="Calibri" pitchFamily="34" charset="-120"/>
-              </a:rPr>
-              <a:t>DETALHAMENTO: </a:t>
-            </a:r>
-            <a:pPr indent="0" marL="0">
-              <a:lnSpc>
-                <a:spcPct val="110000"/>
-              </a:lnSpc>
-              <a:buNone/>
-            </a:pPr>
-            <a:r>
-              <a:rPr lang="en-US" sz="1300" dirty="0">
-                <a:solidFill>
-                  <a:srgbClr val="F0F6FC"/>
-                </a:solidFill>
-                <a:latin typeface="Calibri" pitchFamily="34" charset="0"/>
-                <a:ea typeface="Calibri" pitchFamily="34" charset="-122"/>
-                <a:cs typeface="Calibri" pitchFamily="34" charset="-120"/>
-              </a:rPr>
-              <a:t>restringir a publicidade de bets (como já foi feito com o cigarro), criar cadastro nacional de autoexclusão e bloquear o cadastro de menores com verificação real de identidade.</a:t>
-            </a:r>
-            <a:endParaRPr lang="en-US" sz="1300" dirty="0"/>
           </a:p>
         </p:txBody>
       </p:sp>
@@ -4243,14 +6038,373 @@
       </p:grpSpPr>
       <p:sp>
         <p:nvSpPr>
-          <p:cNvPr id="2" name="Shape 0"/>
+          <p:cNvPr id="2" name="Text 0"/>
+          <p:cNvSpPr txBox="1"/>
+          <p:nvPr/>
+        </p:nvSpPr>
+        <p:spPr>
+          <a:xfrm>
+            <a:off x="640080" y="384048"/>
+            <a:ext cx="2743200" cy="365760"/>
+          </a:xfrm>
+          <a:prstGeom prst="rect">
+            <a:avLst/>
+          </a:prstGeom>
+          <a:noFill/>
+          <a:ln/>
+        </p:spPr>
+        <p:txBody>
+          <a:bodyPr wrap="square" lIns="0" tIns="0" rIns="0" bIns="0" rtlCol="0" anchor="ctr"/>
+          <a:lstStyle/>
+          <a:p>
+            <a:pPr indent="0" marL="0">
+              <a:buNone/>
+            </a:pPr>
+            <a:r>
+              <a:rPr lang="en-US" sz="1500" b="1" spc="400" kern="0" dirty="0">
+                <a:solidFill>
+                  <a:srgbClr val="E3B341"/>
+                </a:solidFill>
+                <a:latin typeface="Calibri" pitchFamily="34" charset="0"/>
+                <a:ea typeface="Calibri" pitchFamily="34" charset="-122"/>
+                <a:cs typeface="Calibri" pitchFamily="34" charset="-120"/>
+              </a:rPr>
+              <a:t>MATEMÁTICA</a:t>
+            </a:r>
+            <a:endParaRPr lang="en-US" sz="1500" dirty="0"/>
+          </a:p>
+        </p:txBody>
+      </p:sp>
+      <p:sp>
+        <p:nvSpPr>
+          <p:cNvPr id="3" name="Text 1"/>
+          <p:cNvSpPr txBox="1"/>
+          <p:nvPr/>
+        </p:nvSpPr>
+        <p:spPr>
+          <a:xfrm>
+            <a:off x="640080" y="749808"/>
+            <a:ext cx="7863840" cy="548640"/>
+          </a:xfrm>
+          <a:prstGeom prst="rect">
+            <a:avLst/>
+          </a:prstGeom>
+          <a:noFill/>
+          <a:ln/>
+        </p:spPr>
+        <p:txBody>
+          <a:bodyPr wrap="square" lIns="0" tIns="0" rIns="0" bIns="0" rtlCol="0" anchor="ctr"/>
+          <a:lstStyle/>
+          <a:p>
+            <a:pPr indent="0" marL="0">
+              <a:buNone/>
+            </a:pPr>
+            <a:r>
+              <a:rPr lang="en-US" sz="2900" b="1" dirty="0">
+                <a:solidFill>
+                  <a:srgbClr val="F0F6FC"/>
+                </a:solidFill>
+                <a:latin typeface="Calibri" pitchFamily="34" charset="0"/>
+                <a:ea typeface="Calibri" pitchFamily="34" charset="-122"/>
+                <a:cs typeface="Calibri" pitchFamily="34" charset="-120"/>
+              </a:rPr>
+              <a:t>O vício em números</a:t>
+            </a:r>
+            <a:endParaRPr lang="en-US" sz="2900" dirty="0"/>
+          </a:p>
+        </p:txBody>
+      </p:sp>
+      <p:graphicFrame>
+        <p:nvGraphicFramePr>
+          <p:cNvPr id="4" name="Chart 0" descr=""/>
+          <p:cNvGraphicFramePr/>
+          <p:nvPr/>
+        </p:nvGraphicFramePr>
+        <p:xfrm>
+          <a:off x="502920" y="1463040"/>
+          <a:ext cx="5212080" cy="2834640"/>
+        </p:xfrm>
+        <a:graphic xmlns:a="http://schemas.openxmlformats.org/drawingml/2006/main">
+          <a:graphicData uri="http://schemas.openxmlformats.org/drawingml/2006/chart">
+            <c:chart xmlns:c="http://schemas.openxmlformats.org/drawingml/2006/chart" r:id="rId1"/>
+          </a:graphicData>
+        </a:graphic>
+      </p:graphicFrame>
+      <p:sp>
+        <p:nvSpPr>
+          <p:cNvPr id="5" name="Text 2"/>
+          <p:cNvSpPr txBox="1"/>
+          <p:nvPr/>
+        </p:nvSpPr>
+        <p:spPr>
+          <a:xfrm>
+            <a:off x="640080" y="4343400"/>
+            <a:ext cx="5029200" cy="320040"/>
+          </a:xfrm>
+          <a:prstGeom prst="rect">
+            <a:avLst/>
+          </a:prstGeom>
+          <a:noFill/>
+          <a:ln/>
+        </p:spPr>
+        <p:txBody>
+          <a:bodyPr wrap="square" lIns="0" tIns="0" rIns="0" bIns="0" rtlCol="0" anchor="ctr"/>
+          <a:lstStyle/>
+          <a:p>
+            <a:pPr indent="0" marL="0">
+              <a:buNone/>
+            </a:pPr>
+            <a:r>
+              <a:rPr lang="en-US" sz="1000" dirty="0">
+                <a:solidFill>
+                  <a:srgbClr val="9BA7B4"/>
+                </a:solidFill>
+                <a:latin typeface="Calibri" pitchFamily="34" charset="0"/>
+                <a:ea typeface="Calibri" pitchFamily="34" charset="-122"/>
+                <a:cs typeface="Calibri" pitchFamily="34" charset="-120"/>
+              </a:rPr>
+              <a:t>Fontes: FIA Business School / Ibevar (2025)</a:t>
+            </a:r>
+            <a:endParaRPr lang="en-US" sz="1000" dirty="0"/>
+          </a:p>
+        </p:txBody>
+      </p:sp>
+      <p:graphicFrame>
+        <p:nvGraphicFramePr>
+          <p:cNvPr id="6" name="Chart 1" descr=""/>
+          <p:cNvGraphicFramePr/>
+          <p:nvPr/>
+        </p:nvGraphicFramePr>
+        <p:xfrm>
+          <a:off x="5943600" y="1417320"/>
+          <a:ext cx="2651760" cy="2651760"/>
+        </p:xfrm>
+        <a:graphic xmlns:a="http://schemas.openxmlformats.org/drawingml/2006/main">
+          <a:graphicData uri="http://schemas.openxmlformats.org/drawingml/2006/chart">
+            <c:chart xmlns:c="http://schemas.openxmlformats.org/drawingml/2006/chart" r:id="rId2"/>
+          </a:graphicData>
+        </a:graphic>
+      </p:graphicFrame>
+      <p:sp>
+        <p:nvSpPr>
+          <p:cNvPr id="7" name="Text 3"/>
+          <p:cNvSpPr txBox="1"/>
+          <p:nvPr/>
+        </p:nvSpPr>
+        <p:spPr>
+          <a:xfrm>
+            <a:off x="5943600" y="2377440"/>
+            <a:ext cx="2651760" cy="640080"/>
+          </a:xfrm>
+          <a:prstGeom prst="rect">
+            <a:avLst/>
+          </a:prstGeom>
+          <a:noFill/>
+          <a:ln/>
+        </p:spPr>
+        <p:txBody>
+          <a:bodyPr wrap="square" lIns="0" tIns="0" rIns="0" bIns="0" rtlCol="0" anchor="ctr"/>
+          <a:lstStyle/>
+          <a:p>
+            <a:pPr algn="ctr" indent="0" marL="0">
+              <a:buNone/>
+            </a:pPr>
+            <a:r>
+              <a:rPr lang="en-US" sz="3000" b="1" dirty="0">
+                <a:solidFill>
+                  <a:srgbClr val="F85149"/>
+                </a:solidFill>
+                <a:latin typeface="Calibri" pitchFamily="34" charset="0"/>
+                <a:ea typeface="Calibri" pitchFamily="34" charset="-122"/>
+                <a:cs typeface="Calibri" pitchFamily="34" charset="-120"/>
+              </a:rPr>
+              <a:t>10,5%</a:t>
+            </a:r>
+            <a:endParaRPr lang="en-US" sz="3000" dirty="0"/>
+          </a:p>
+        </p:txBody>
+      </p:sp>
+      <p:sp>
+        <p:nvSpPr>
+          <p:cNvPr id="8" name="Text 4"/>
+          <p:cNvSpPr txBox="1"/>
+          <p:nvPr/>
+        </p:nvSpPr>
+        <p:spPr>
+          <a:xfrm>
+            <a:off x="5806440" y="4114800"/>
+            <a:ext cx="2926080" cy="777240"/>
+          </a:xfrm>
+          <a:prstGeom prst="rect">
+            <a:avLst/>
+          </a:prstGeom>
+          <a:noFill/>
+          <a:ln/>
+        </p:spPr>
+        <p:txBody>
+          <a:bodyPr wrap="square" lIns="0" tIns="0" rIns="0" bIns="0" rtlCol="0" anchor="t"/>
+          <a:lstStyle/>
+          <a:p>
+            <a:pPr algn="ctr" indent="0" marL="0">
+              <a:buNone/>
+            </a:pPr>
+            <a:r>
+              <a:rPr lang="en-US" sz="1100" dirty="0">
+                <a:solidFill>
+                  <a:srgbClr val="9BA7B4"/>
+                </a:solidFill>
+                <a:latin typeface="Calibri" pitchFamily="34" charset="0"/>
+                <a:ea typeface="Calibri" pitchFamily="34" charset="-122"/>
+                <a:cs typeface="Calibri" pitchFamily="34" charset="-120"/>
+              </a:rPr>
+              <a:t>dos adolescentes de 14 a 17 anos apostaram no último ano — mesmo sendo proibido (Fiocruz)</a:t>
+            </a:r>
+            <a:endParaRPr lang="en-US" sz="1100" dirty="0"/>
+          </a:p>
+        </p:txBody>
+      </p:sp>
+    </p:spTree>
+  </p:cSld>
+  <p:clrMapOvr>
+    <a:masterClrMapping/>
+  </p:clrMapOvr>
+</p:sld>
+</file>
+
+<file path=ppt/slides/slide9.xml><?xml version="1.0" encoding="utf-8"?>
+<p:sld xmlns:a="http://schemas.openxmlformats.org/drawingml/2006/main" xmlns:r="http://schemas.openxmlformats.org/officeDocument/2006/relationships" xmlns:p="http://schemas.openxmlformats.org/presentationml/2006/main">
+  <p:cSld name="Slide 9">
+    <p:bg>
+      <p:bgPr>
+        <a:solidFill>
+          <a:srgbClr val="0D1117"/>
+        </a:solidFill>
+      </p:bgPr>
+    </p:bg>
+    <p:spTree>
+      <p:nvGrpSpPr>
+        <p:cNvPr id="1" name=""/>
+        <p:cNvGrpSpPr/>
+        <p:nvPr/>
+      </p:nvGrpSpPr>
+      <p:grpSpPr>
+        <a:xfrm>
+          <a:off x="0" y="0"/>
+          <a:ext cx="0" cy="0"/>
+          <a:chOff x="0" y="0"/>
+          <a:chExt cx="0" cy="0"/>
+        </a:xfrm>
+      </p:grpSpPr>
+      <p:sp>
+        <p:nvSpPr>
+          <p:cNvPr id="2" name="Text 0"/>
+          <p:cNvSpPr txBox="1"/>
+          <p:nvPr/>
+        </p:nvSpPr>
+        <p:spPr>
+          <a:xfrm>
+            <a:off x="640080" y="384048"/>
+            <a:ext cx="2743200" cy="365760"/>
+          </a:xfrm>
+          <a:prstGeom prst="rect">
+            <a:avLst/>
+          </a:prstGeom>
+          <a:noFill/>
+          <a:ln/>
+        </p:spPr>
+        <p:txBody>
+          <a:bodyPr wrap="square" lIns="0" tIns="0" rIns="0" bIns="0" rtlCol="0" anchor="ctr"/>
+          <a:lstStyle/>
+          <a:p>
+            <a:pPr indent="0" marL="0">
+              <a:buNone/>
+            </a:pPr>
+            <a:r>
+              <a:rPr lang="en-US" sz="1500" b="1" spc="400" kern="0" dirty="0">
+                <a:solidFill>
+                  <a:srgbClr val="F85149"/>
+                </a:solidFill>
+                <a:latin typeface="Calibri" pitchFamily="34" charset="0"/>
+                <a:ea typeface="Calibri" pitchFamily="34" charset="-122"/>
+                <a:cs typeface="Calibri" pitchFamily="34" charset="-120"/>
+              </a:rPr>
+              <a:t>BIOLOGIA</a:t>
+            </a:r>
+            <a:endParaRPr lang="en-US" sz="1500" dirty="0"/>
+          </a:p>
+        </p:txBody>
+      </p:sp>
+      <p:sp>
+        <p:nvSpPr>
+          <p:cNvPr id="3" name="Text 1"/>
+          <p:cNvSpPr txBox="1"/>
+          <p:nvPr/>
+        </p:nvSpPr>
+        <p:spPr>
+          <a:xfrm>
+            <a:off x="640080" y="749808"/>
+            <a:ext cx="7863840" cy="548640"/>
+          </a:xfrm>
+          <a:prstGeom prst="rect">
+            <a:avLst/>
+          </a:prstGeom>
+          <a:noFill/>
+          <a:ln/>
+        </p:spPr>
+        <p:txBody>
+          <a:bodyPr wrap="square" lIns="0" tIns="0" rIns="0" bIns="0" rtlCol="0" anchor="ctr"/>
+          <a:lstStyle/>
+          <a:p>
+            <a:pPr indent="0" marL="0">
+              <a:buNone/>
+            </a:pPr>
+            <a:r>
+              <a:rPr lang="en-US" sz="2900" b="1" dirty="0">
+                <a:solidFill>
+                  <a:srgbClr val="F0F6FC"/>
+                </a:solidFill>
+                <a:latin typeface="Calibri" pitchFamily="34" charset="0"/>
+                <a:ea typeface="Calibri" pitchFamily="34" charset="-122"/>
+                <a:cs typeface="Calibri" pitchFamily="34" charset="-120"/>
+              </a:rPr>
+              <a:t>O que a aposta faz no cérebro</a:t>
+            </a:r>
+            <a:endParaRPr lang="en-US" sz="2900" dirty="0"/>
+          </a:p>
+        </p:txBody>
+      </p:sp>
+      <p:sp>
+        <p:nvSpPr>
+          <p:cNvPr id="4" name="Shape 2"/>
           <p:cNvSpPr/>
           <p:nvPr/>
         </p:nvSpPr>
         <p:spPr>
           <a:xfrm>
-            <a:off x="640080" y="457200"/>
-            <a:ext cx="777240" cy="777240"/>
+            <a:off x="640080" y="1463040"/>
+            <a:ext cx="7863840" cy="987552"/>
+          </a:xfrm>
+          <a:prstGeom prst="roundRect">
+            <a:avLst>
+              <a:gd name="adj" fmla="val 9259"/>
+            </a:avLst>
+          </a:prstGeom>
+          <a:solidFill>
+            <a:srgbClr val="161C26"/>
+          </a:solidFill>
+          <a:ln/>
+        </p:spPr>
+      </p:sp>
+      <p:sp>
+        <p:nvSpPr>
+          <p:cNvPr id="5" name="Shape 3"/>
+          <p:cNvSpPr/>
+          <p:nvPr/>
+        </p:nvSpPr>
+        <p:spPr>
+          <a:xfrm>
+            <a:off x="804672" y="1700784"/>
+            <a:ext cx="512064" cy="512064"/>
           </a:xfrm>
           <a:prstGeom prst="ellipse">
             <a:avLst/>
@@ -4263,7 +6417,7 @@
       </p:sp>
       <p:pic>
         <p:nvPicPr>
-          <p:cNvPr id="3" name="Image 0" descr="preencoded.png">    </p:cNvPr>
+          <p:cNvPr id="6" name="Image 0" descr="preencoded.png">    </p:cNvPr>
           <p:cNvPicPr>
             <a:picLocks noChangeAspect="1"/>
           </p:cNvPicPr>
@@ -4277,8 +6431,8 @@
         </p:blipFill>
         <p:spPr>
           <a:xfrm>
-            <a:off x="842162" y="659282"/>
-            <a:ext cx="373075" cy="373075"/>
+            <a:off x="937809" y="1833921"/>
+            <a:ext cx="245791" cy="245791"/>
           </a:xfrm>
           <a:prstGeom prst="rect">
             <a:avLst/>
@@ -4287,53 +6441,14 @@
       </p:pic>
       <p:sp>
         <p:nvSpPr>
-          <p:cNvPr id="4" name="Text 1"/>
+          <p:cNvPr id="7" name="Text 4"/>
           <p:cNvSpPr txBox="1"/>
           <p:nvPr/>
         </p:nvSpPr>
         <p:spPr>
           <a:xfrm>
-            <a:off x="1645920" y="566928"/>
-            <a:ext cx="6858000" cy="594360"/>
-          </a:xfrm>
-          <a:prstGeom prst="rect">
-            <a:avLst/>
-          </a:prstGeom>
-          <a:noFill/>
-          <a:ln/>
-        </p:spPr>
-        <p:txBody>
-          <a:bodyPr wrap="square" lIns="0" tIns="0" rIns="0" bIns="0" rtlCol="0" anchor="ctr"/>
-          <a:lstStyle/>
-          <a:p>
-            <a:pPr indent="0" marL="0">
-              <a:buNone/>
-            </a:pPr>
-            <a:r>
-              <a:rPr lang="en-US" sz="2600" b="1" dirty="0">
-                <a:solidFill>
-                  <a:srgbClr val="F0F6FC"/>
-                </a:solidFill>
-                <a:latin typeface="Calibri" pitchFamily="34" charset="0"/>
-                <a:ea typeface="Calibri" pitchFamily="34" charset="-122"/>
-                <a:cs typeface="Calibri" pitchFamily="34" charset="-120"/>
-              </a:rPr>
-              <a:t>A CASA NÃO PRECISA VENCER SEMPRE</a:t>
-            </a:r>
-            <a:endParaRPr lang="en-US" sz="2600" dirty="0"/>
-          </a:p>
-        </p:txBody>
-      </p:sp>
-      <p:sp>
-        <p:nvSpPr>
-          <p:cNvPr id="5" name="Text 2"/>
-          <p:cNvSpPr txBox="1"/>
-          <p:nvPr/>
-        </p:nvSpPr>
-        <p:spPr>
-          <a:xfrm>
-            <a:off x="640080" y="1463040"/>
-            <a:ext cx="7863840" cy="1051560"/>
+            <a:off x="1481328" y="1536192"/>
+            <a:ext cx="6858000" cy="868680"/>
           </a:xfrm>
           <a:prstGeom prst="rect">
             <a:avLst/>
@@ -4347,12 +6462,30 @@
           <a:p>
             <a:pPr indent="0" marL="0">
               <a:lnSpc>
-                <a:spcPct val="115000"/>
+                <a:spcPct val="105000"/>
               </a:lnSpc>
               <a:buNone/>
             </a:pPr>
             <a:r>
-              <a:rPr lang="en-US" sz="1600" dirty="0">
+              <a:rPr lang="en-US" sz="1250" b="1" dirty="0">
+                <a:solidFill>
+                  <a:srgbClr val="F85149"/>
+                </a:solidFill>
+                <a:latin typeface="Calibri" pitchFamily="34" charset="0"/>
+                <a:ea typeface="Calibri" pitchFamily="34" charset="-122"/>
+                <a:cs typeface="Calibri" pitchFamily="34" charset="-120"/>
+              </a:rPr>
+              <a:t>Dopamina e o circuito de recompensa
+</a:t>
+            </a:r>
+            <a:pPr indent="0" marL="0">
+              <a:lnSpc>
+                <a:spcPct val="105000"/>
+              </a:lnSpc>
+              <a:buNone/>
+            </a:pPr>
+            <a:r>
+              <a:rPr lang="en-US" sz="1100" dirty="0">
                 <a:solidFill>
                   <a:srgbClr val="F0F6FC"/>
                 </a:solidFill>
@@ -4360,26 +6493,26 @@
                 <a:ea typeface="Calibri" pitchFamily="34" charset="-122"/>
                 <a:cs typeface="Calibri" pitchFamily="34" charset="-120"/>
               </a:rPr>
-              <a:t>Vício em aposta é doença, tem tratamento gratuito no SUS/CAPS e ninguém deve enfrentar isso sozinho. Informação é a melhor aposta: por isso nosso grupo também produziu um vídeo ensinando como identificar e combater o vício em bets.</a:t>
-            </a:r>
-            <a:endParaRPr lang="en-US" sz="1600" dirty="0"/>
-          </a:p>
-        </p:txBody>
-      </p:sp>
-      <p:sp>
-        <p:nvSpPr>
-          <p:cNvPr id="6" name="Shape 3"/>
+              <a:t>Cada aposta libera dopamina no sistema de recompensa (núcleo accumbens). Recompensa IMPREVISÍVEL libera mais dopamina do que recompensa certa — por isso o 'quase ganhei' vicia tanto quanto ganhar.</a:t>
+            </a:r>
+            <a:endParaRPr lang="en-US" sz="1250" dirty="0"/>
+          </a:p>
+        </p:txBody>
+      </p:sp>
+      <p:sp>
+        <p:nvSpPr>
+          <p:cNvPr id="8" name="Shape 5"/>
           <p:cNvSpPr/>
           <p:nvPr/>
         </p:nvSpPr>
         <p:spPr>
           <a:xfrm>
-            <a:off x="640080" y="2651760"/>
-            <a:ext cx="3840480" cy="1051560"/>
+            <a:off x="640080" y="2578608"/>
+            <a:ext cx="7863840" cy="987552"/>
           </a:xfrm>
           <a:prstGeom prst="roundRect">
             <a:avLst>
-              <a:gd name="adj" fmla="val 8696"/>
+              <a:gd name="adj" fmla="val 9259"/>
             </a:avLst>
           </a:prstGeom>
           <a:solidFill>
@@ -4390,14 +6523,58 @@
       </p:sp>
       <p:sp>
         <p:nvSpPr>
-          <p:cNvPr id="7" name="Text 4"/>
+          <p:cNvPr id="9" name="Shape 6"/>
+          <p:cNvSpPr/>
+          <p:nvPr/>
+        </p:nvSpPr>
+        <p:spPr>
+          <a:xfrm>
+            <a:off x="804672" y="2816352"/>
+            <a:ext cx="512064" cy="512064"/>
+          </a:xfrm>
+          <a:prstGeom prst="ellipse">
+            <a:avLst/>
+          </a:prstGeom>
+          <a:solidFill>
+            <a:srgbClr val="1C2431"/>
+          </a:solidFill>
+          <a:ln/>
+        </p:spPr>
+      </p:sp>
+      <p:pic>
+        <p:nvPicPr>
+          <p:cNvPr id="10" name="Image 1" descr="preencoded.png">    </p:cNvPr>
+          <p:cNvPicPr>
+            <a:picLocks noChangeAspect="1"/>
+          </p:cNvPicPr>
+          <p:nvPr/>
+        </p:nvPicPr>
+        <p:blipFill>
+          <a:blip r:embed="rId2"/>
+          <a:stretch>
+            <a:fillRect/>
+          </a:stretch>
+        </p:blipFill>
+        <p:spPr>
+          <a:xfrm>
+            <a:off x="937809" y="2949489"/>
+            <a:ext cx="245791" cy="245791"/>
+          </a:xfrm>
+          <a:prstGeom prst="rect">
+            <a:avLst/>
+          </a:prstGeom>
+        </p:spPr>
+      </p:pic>
+      <p:sp>
+        <p:nvSpPr>
+          <p:cNvPr id="11" name="Text 7"/>
           <p:cNvSpPr txBox="1"/>
           <p:nvPr/>
         </p:nvSpPr>
         <p:spPr>
           <a:xfrm>
-            <a:off x="822960" y="2743200"/>
-            <a:ext cx="3474720" cy="868680"/>
+            <a:off x="1481328" y="2651760"/>
+            <a:ext cx="6858000" cy="868680"/>
           </a:xfrm>
           <a:prstGeom prst="rect">
             <a:avLst/>
@@ -4411,30 +6588,30 @@
           <a:p>
             <a:pPr indent="0" marL="0">
               <a:lnSpc>
-                <a:spcPct val="110000"/>
+                <a:spcPct val="105000"/>
               </a:lnSpc>
               <a:buNone/>
             </a:pPr>
             <a:r>
-              <a:rPr lang="en-US" sz="1300" b="1" dirty="0">
-                <a:solidFill>
-                  <a:srgbClr val="3FB950"/>
-                </a:solidFill>
-                <a:latin typeface="Calibri" pitchFamily="34" charset="0"/>
-                <a:ea typeface="Calibri" pitchFamily="34" charset="-122"/>
-                <a:cs typeface="Calibri" pitchFamily="34" charset="-120"/>
-              </a:rPr>
-              <a:t>ONDE BUSCAR AJUDA
+              <a:rPr lang="en-US" sz="1250" b="1" dirty="0">
+                <a:solidFill>
+                  <a:srgbClr val="F85149"/>
+                </a:solidFill>
+                <a:latin typeface="Calibri" pitchFamily="34" charset="0"/>
+                <a:ea typeface="Calibri" pitchFamily="34" charset="-122"/>
+                <a:cs typeface="Calibri" pitchFamily="34" charset="-120"/>
+              </a:rPr>
+              <a:t>Tolerância: o mesmo mecanismo das drogas
 </a:t>
             </a:r>
             <a:pPr indent="0" marL="0">
               <a:lnSpc>
-                <a:spcPct val="110000"/>
+                <a:spcPct val="105000"/>
               </a:lnSpc>
               <a:buNone/>
             </a:pPr>
             <a:r>
-              <a:rPr lang="en-US" sz="1250" dirty="0">
+              <a:rPr lang="en-US" sz="1100" dirty="0">
                 <a:solidFill>
                   <a:srgbClr val="F0F6FC"/>
                 </a:solidFill>
@@ -4442,26 +6619,26 @@
                 <a:ea typeface="Calibri" pitchFamily="34" charset="-122"/>
                 <a:cs typeface="Calibri" pitchFamily="34" charset="-120"/>
               </a:rPr>
-              <a:t>CAPS (SUS) • Jogadores Anônimos • CVV: ligue 188 (24h, gratuito)</a:t>
-            </a:r>
-            <a:endParaRPr lang="en-US" sz="1300" dirty="0"/>
-          </a:p>
-        </p:txBody>
-      </p:sp>
-      <p:sp>
-        <p:nvSpPr>
-          <p:cNvPr id="8" name="Shape 5"/>
+              <a:t>Com a repetição, o cérebro reduz a sensibilidade dos receptores de dopamina. Resultado: é preciso apostar mais, e mais alto, para sentir o mesmo prazer — a definição biológica de dependência (CID-11, OMS).</a:t>
+            </a:r>
+            <a:endParaRPr lang="en-US" sz="1250" dirty="0"/>
+          </a:p>
+        </p:txBody>
+      </p:sp>
+      <p:sp>
+        <p:nvSpPr>
+          <p:cNvPr id="12" name="Shape 8"/>
           <p:cNvSpPr/>
           <p:nvPr/>
         </p:nvSpPr>
         <p:spPr>
           <a:xfrm>
-            <a:off x="4663440" y="2651760"/>
-            <a:ext cx="3840480" cy="1051560"/>
+            <a:off x="640080" y="3694176"/>
+            <a:ext cx="7863840" cy="987552"/>
           </a:xfrm>
           <a:prstGeom prst="roundRect">
             <a:avLst>
-              <a:gd name="adj" fmla="val 8696"/>
+              <a:gd name="adj" fmla="val 9259"/>
             </a:avLst>
           </a:prstGeom>
           <a:solidFill>
@@ -4472,14 +6649,58 @@
       </p:sp>
       <p:sp>
         <p:nvSpPr>
-          <p:cNvPr id="9" name="Text 6"/>
+          <p:cNvPr id="13" name="Shape 9"/>
+          <p:cNvSpPr/>
+          <p:nvPr/>
+        </p:nvSpPr>
+        <p:spPr>
+          <a:xfrm>
+            <a:off x="804672" y="3931920"/>
+            <a:ext cx="512064" cy="512064"/>
+          </a:xfrm>
+          <a:prstGeom prst="ellipse">
+            <a:avLst/>
+          </a:prstGeom>
+          <a:solidFill>
+            <a:srgbClr val="1C2431"/>
+          </a:solidFill>
+          <a:ln/>
+        </p:spPr>
+      </p:sp>
+      <p:pic>
+        <p:nvPicPr>
+          <p:cNvPr id="14" name="Image 2" descr="preencoded.png">    </p:cNvPr>
+          <p:cNvPicPr>
+            <a:picLocks noChangeAspect="1"/>
+          </p:cNvPicPr>
+          <p:nvPr/>
+        </p:nvPicPr>
+        <p:blipFill>
+          <a:blip r:embed="rId3"/>
+          <a:stretch>
+            <a:fillRect/>
+          </a:stretch>
+        </p:blipFill>
+        <p:spPr>
+          <a:xfrm>
+            <a:off x="937809" y="4065057"/>
+            <a:ext cx="245791" cy="245791"/>
+          </a:xfrm>
+          <a:prstGeom prst="rect">
+            <a:avLst/>
+          </a:prstGeom>
+        </p:spPr>
+      </p:pic>
+      <p:sp>
+        <p:nvSpPr>
+          <p:cNvPr id="15" name="Text 10"/>
           <p:cNvSpPr txBox="1"/>
           <p:nvPr/>
         </p:nvSpPr>
         <p:spPr>
           <a:xfrm>
-            <a:off x="4846320" y="2743200"/>
-            <a:ext cx="3474720" cy="868680"/>
+            <a:off x="1481328" y="3767328"/>
+            <a:ext cx="6858000" cy="868680"/>
           </a:xfrm>
           <a:prstGeom prst="rect">
             <a:avLst/>
@@ -4493,12 +6714,12 @@
           <a:p>
             <a:pPr indent="0" marL="0">
               <a:lnSpc>
-                <a:spcPct val="110000"/>
+                <a:spcPct val="105000"/>
               </a:lnSpc>
               <a:buNone/>
             </a:pPr>
             <a:r>
-              <a:rPr lang="en-US" sz="1300" b="1" dirty="0">
+              <a:rPr lang="en-US" sz="1250" b="1" dirty="0">
                 <a:solidFill>
                   <a:srgbClr val="F85149"/>
                 </a:solidFill>
@@ -4506,17 +6727,17 @@
                 <a:ea typeface="Calibri" pitchFamily="34" charset="-122"/>
                 <a:cs typeface="Calibri" pitchFamily="34" charset="-120"/>
               </a:rPr>
-              <a:t>SINAIS DE ALERTA
+              <a:t>Por que o adolescente é mais vulnerável
 </a:t>
             </a:r>
             <a:pPr indent="0" marL="0">
               <a:lnSpc>
-                <a:spcPct val="110000"/>
+                <a:spcPct val="105000"/>
               </a:lnSpc>
               <a:buNone/>
             </a:pPr>
             <a:r>
-              <a:rPr lang="en-US" sz="1250" dirty="0">
+              <a:rPr lang="en-US" sz="1100" dirty="0">
                 <a:solidFill>
                   <a:srgbClr val="F0F6FC"/>
                 </a:solidFill>
@@ -4524,51 +6745,9 @@
                 <a:ea typeface="Calibri" pitchFamily="34" charset="-122"/>
                 <a:cs typeface="Calibri" pitchFamily="34" charset="-120"/>
               </a:rPr>
-              <a:t>Apostar escondido • apostar para recuperar perdas • usar dinheiro de contas • irritação ao tentar parar</a:t>
-            </a:r>
-            <a:endParaRPr lang="en-US" sz="1300" dirty="0"/>
-          </a:p>
-        </p:txBody>
-      </p:sp>
-      <p:sp>
-        <p:nvSpPr>
-          <p:cNvPr id="10" name="Text 7"/>
-          <p:cNvSpPr txBox="1"/>
-          <p:nvPr/>
-        </p:nvSpPr>
-        <p:spPr>
-          <a:xfrm>
-            <a:off x="640080" y="4160520"/>
-            <a:ext cx="7863840" cy="640080"/>
-          </a:xfrm>
-          <a:prstGeom prst="rect">
-            <a:avLst/>
-          </a:prstGeom>
-          <a:noFill/>
-          <a:ln/>
-        </p:spPr>
-        <p:txBody>
-          <a:bodyPr wrap="square" lIns="0" tIns="0" rIns="0" bIns="0" rtlCol="0" anchor="ctr"/>
-          <a:lstStyle/>
-          <a:p>
-            <a:pPr indent="0" marL="0">
-              <a:lnSpc>
-                <a:spcPct val="110000"/>
-              </a:lnSpc>
-              <a:buNone/>
-            </a:pPr>
-            <a:r>
-              <a:rPr lang="en-US" sz="1050" dirty="0">
-                <a:solidFill>
-                  <a:srgbClr val="9BA7B4"/>
-                </a:solidFill>
-                <a:latin typeface="Calibri" pitchFamily="34" charset="0"/>
-                <a:ea typeface="Calibri" pitchFamily="34" charset="-122"/>
-                <a:cs typeface="Calibri" pitchFamily="34" charset="-120"/>
-              </a:rPr>
-              <a:t>Fontes: Fiocruz (Radis) • Agência Brasil / Ministério da Saúde • Associação Brasileira de Psiquiatria • Banco Central • FIA Business School / Ibevar • Associação Médica Brasileira</a:t>
-            </a:r>
-            <a:endParaRPr lang="en-US" sz="1050" dirty="0"/>
+              <a:t>O córtex pré-frontal — a área que freia impulsos e avalia riscos — só termina de amadurecer por volta dos 25 anos. Cérebro em formação + app desenhado para viciar é uma disputa desleal.</a:t>
+            </a:r>
+            <a:endParaRPr lang="en-US" sz="1250" dirty="0"/>
           </a:p>
         </p:txBody>
       </p:sp>

</xml_diff>

<commit_message>
Preenche capa com integrantes, turma e professores
Co-Authored-By: Claude Fable 5 <noreply@anthropic.com>
Claude-Session: https://claude.ai/code/session_016ibD7bSDuWkAH5YBCiU9BC
</commit_message>
<xml_diff>
--- a/trabalho-vicio-em-bets/vicio-em-bets.pptx
+++ b/trabalho-vicio-em-bets/vicio-em-bets.pptx
@@ -2730,7 +2730,7 @@
                 <a:ea typeface="Calibri" pitchFamily="34" charset="-122"/>
                 <a:cs typeface="Calibri" pitchFamily="34" charset="-120"/>
               </a:rPr>
-              <a:t>Redação: tese e intervenção  •  Matemática: os números  •  Biologia: o cérebro no vício</a:t>
+              <a:t>Trabalho interdisciplinar  —  Redação  •  Matemática  •  Biologia</a:t>
             </a:r>
             <a:endParaRPr lang="en-US" sz="1400" dirty="0"/>
           </a:p>
@@ -2744,7 +2744,7 @@
         </p:nvSpPr>
         <p:spPr>
           <a:xfrm>
-            <a:off x="640080" y="4343400"/>
+            <a:off x="640080" y="4160520"/>
             <a:ext cx="7863840" cy="365760"/>
           </a:xfrm>
           <a:prstGeom prst="rect">
@@ -2761,7 +2761,46 @@
               <a:buNone/>
             </a:pPr>
             <a:r>
-              <a:rPr lang="en-US" sz="1300" dirty="0">
+              <a:rPr lang="en-US" sz="1400" b="1" dirty="0">
+                <a:solidFill>
+                  <a:srgbClr val="F0F6FC"/>
+                </a:solidFill>
+                <a:latin typeface="Calibri" pitchFamily="34" charset="0"/>
+                <a:ea typeface="Calibri" pitchFamily="34" charset="-122"/>
+                <a:cs typeface="Calibri" pitchFamily="34" charset="-120"/>
+              </a:rPr>
+              <a:t>João Victor e Najib  —  Turma 3B  —  2026</a:t>
+            </a:r>
+            <a:endParaRPr lang="en-US" sz="1400" dirty="0"/>
+          </a:p>
+        </p:txBody>
+      </p:sp>
+      <p:sp>
+        <p:nvSpPr>
+          <p:cNvPr id="7" name="Text 4"/>
+          <p:cNvSpPr txBox="1"/>
+          <p:nvPr/>
+        </p:nvSpPr>
+        <p:spPr>
+          <a:xfrm>
+            <a:off x="640080" y="4553712"/>
+            <a:ext cx="7863840" cy="365760"/>
+          </a:xfrm>
+          <a:prstGeom prst="rect">
+            <a:avLst/>
+          </a:prstGeom>
+          <a:noFill/>
+          <a:ln/>
+        </p:spPr>
+        <p:txBody>
+          <a:bodyPr wrap="square" lIns="0" tIns="0" rIns="0" bIns="0" rtlCol="0" anchor="ctr"/>
+          <a:lstStyle/>
+          <a:p>
+            <a:pPr algn="l" indent="0" marL="0">
+              <a:buNone/>
+            </a:pPr>
+            <a:r>
+              <a:rPr lang="en-US" sz="1200" dirty="0">
                 <a:solidFill>
                   <a:srgbClr val="9BA7B4"/>
                 </a:solidFill>
@@ -2769,9 +2808,9 @@
                 <a:ea typeface="Calibri" pitchFamily="34" charset="-122"/>
                 <a:cs typeface="Calibri" pitchFamily="34" charset="-120"/>
               </a:rPr>
-              <a:t>[Nomes dos integrantes]  —  [Turma]  —  2026</a:t>
-            </a:r>
-            <a:endParaRPr lang="en-US" sz="1300" dirty="0"/>
+              <a:t>Professores: Tiago (Matemática)  •  Cristina (Biologia)  •  Karen (Redação)</a:t>
+            </a:r>
+            <a:endParaRPr lang="en-US" sz="1200" dirty="0"/>
           </a:p>
         </p:txBody>
       </p:sp>

</xml_diff>

<commit_message>
Atualiza título da capa para o tema oficial do trabalho
Co-Authored-By: Claude Fable 5 <noreply@anthropic.com>
Claude-Session: https://claude.ai/code/session_016ibD7bSDuWkAH5YBCiU9BC
</commit_message>
<xml_diff>
--- a/trabalho-vicio-em-bets/vicio-em-bets.pptx
+++ b/trabalho-vicio-em-bets/vicio-em-bets.pptx
@@ -2601,8 +2601,8 @@
         </p:nvSpPr>
         <p:spPr>
           <a:xfrm>
-            <a:off x="548640" y="1234440"/>
-            <a:ext cx="8046720" cy="868680"/>
+            <a:off x="548640" y="1051560"/>
+            <a:ext cx="8046720" cy="1234440"/>
           </a:xfrm>
           <a:prstGeom prst="rect">
             <a:avLst/>
@@ -2618,7 +2618,7 @@
               <a:buNone/>
             </a:pPr>
             <a:r>
-              <a:rPr lang="en-US" sz="4400" b="1" dirty="0">
+              <a:rPr lang="en-US" sz="3600" b="1" dirty="0">
                 <a:solidFill>
                   <a:srgbClr val="1F3864"/>
                 </a:solidFill>
@@ -2626,9 +2626,9 @@
                 <a:ea typeface="Calibri" pitchFamily="34" charset="-122"/>
                 <a:cs typeface="Calibri" pitchFamily="34" charset="-120"/>
               </a:rPr>
-              <a:t>O vício em bets no Brasil</a:t>
-            </a:r>
-            <a:endParaRPr lang="en-US" sz="4400" dirty="0"/>
+              <a:t>Desafios para combater o vício em bets no Brasil</a:t>
+            </a:r>
+            <a:endParaRPr lang="en-US" sz="3600" dirty="0"/>
           </a:p>
         </p:txBody>
       </p:sp>
@@ -2640,7 +2640,7 @@
         </p:nvSpPr>
         <p:spPr>
           <a:xfrm>
-            <a:off x="548640" y="2148840"/>
+            <a:off x="548640" y="2331720"/>
             <a:ext cx="8046720" cy="457200"/>
           </a:xfrm>
           <a:prstGeom prst="rect">

</xml_diff>